<commit_message>
Naming and documentation updated
</commit_message>
<xml_diff>
--- a/CSS_examples/Documentation && Report/CSS works.pptx
+++ b/CSS_examples/Documentation && Report/CSS works.pptx
@@ -229,7 +229,7 @@
           <a:p>
             <a:fld id="{0B851660-0934-124D-A4B3-496C7F320307}" type="datetimeFigureOut">
               <a:rPr lang="de-DE" smtClean="0"/>
-              <a:t>20.08.2026</a:t>
+              <a:t>24.08.2026</a:t>
             </a:fld>
             <a:endParaRPr lang="de-DE"/>
           </a:p>
@@ -395,7 +395,7 @@
           <a:p>
             <a:fld id="{98C828EF-C252-394A-93BF-1C478CFA0896}" type="datetimeFigureOut">
               <a:rPr lang="de-DE" smtClean="0"/>
-              <a:t>20.08.2026</a:t>
+              <a:t>24.08.2026</a:t>
             </a:fld>
             <a:endParaRPr lang="de-DE"/>
           </a:p>
@@ -6846,7 +6846,7 @@
               <a:buAutoNum type="arabicPeriod"/>
             </a:pPr>
             <a:r>
-              <a:rPr lang="de-DE" sz="1400" dirty="0" err="1">
+              <a:rPr lang="de-DE" sz="1400" strike="sngStrike" dirty="0" err="1">
                 <a:solidFill>
                   <a:schemeClr val="tx1"/>
                 </a:solidFill>
@@ -6854,7 +6854,7 @@
               <a:t>naming</a:t>
             </a:r>
             <a:r>
-              <a:rPr lang="de-DE" sz="1400" dirty="0">
+              <a:rPr lang="de-DE" sz="1400" strike="sngStrike" dirty="0">
                 <a:solidFill>
                   <a:schemeClr val="tx1"/>
                 </a:solidFill>
@@ -6862,7 +6862,7 @@
               <a:t> and README </a:t>
             </a:r>
             <a:r>
-              <a:rPr lang="de-DE" sz="1400" dirty="0" err="1">
+              <a:rPr lang="de-DE" sz="1400" strike="sngStrike" dirty="0" err="1">
                 <a:solidFill>
                   <a:schemeClr val="tx1"/>
                 </a:solidFill>
@@ -6870,7 +6870,7 @@
               <a:t>files</a:t>
             </a:r>
             <a:r>
-              <a:rPr lang="de-DE" sz="1400" dirty="0">
+              <a:rPr lang="de-DE" sz="1400" strike="sngStrike" dirty="0">
                 <a:solidFill>
                   <a:schemeClr val="tx1"/>
                 </a:solidFill>
@@ -6878,7 +6878,7 @@
               <a:t> </a:t>
             </a:r>
             <a:r>
-              <a:rPr lang="de-DE" sz="1400" dirty="0" err="1">
+              <a:rPr lang="de-DE" sz="1400" strike="sngStrike" dirty="0" err="1">
                 <a:solidFill>
                   <a:schemeClr val="tx1"/>
                 </a:solidFill>
@@ -6886,7 +6886,7 @@
               <a:t>should</a:t>
             </a:r>
             <a:r>
-              <a:rPr lang="de-DE" sz="1400" dirty="0">
+              <a:rPr lang="de-DE" sz="1400" strike="sngStrike" dirty="0">
                 <a:solidFill>
                   <a:schemeClr val="tx1"/>
                 </a:solidFill>
@@ -6894,7 +6894,7 @@
               <a:t> </a:t>
             </a:r>
             <a:r>
-              <a:rPr lang="de-DE" sz="1400" dirty="0" err="1">
+              <a:rPr lang="de-DE" sz="1400" strike="sngStrike" dirty="0" err="1">
                 <a:solidFill>
                   <a:schemeClr val="tx1"/>
                 </a:solidFill>
@@ -6902,7 +6902,7 @@
               <a:t>be</a:t>
             </a:r>
             <a:r>
-              <a:rPr lang="de-DE" sz="1400" dirty="0">
+              <a:rPr lang="de-DE" sz="1400" strike="sngStrike" dirty="0">
                 <a:solidFill>
                   <a:schemeClr val="tx1"/>
                 </a:solidFill>
@@ -6910,7 +6910,7 @@
               <a:t> </a:t>
             </a:r>
             <a:r>
-              <a:rPr lang="de-DE" sz="1400" dirty="0" err="1">
+              <a:rPr lang="de-DE" sz="1400" strike="sngStrike" dirty="0" err="1">
                 <a:solidFill>
                   <a:schemeClr val="tx1"/>
                 </a:solidFill>
@@ -6918,14 +6918,124 @@
               <a:t>done</a:t>
             </a:r>
             <a:r>
-              <a:rPr lang="de-DE" sz="1400">
+              <a:rPr lang="de-DE" sz="1400" strike="sngStrike" dirty="0">
                 <a:solidFill>
                   <a:schemeClr val="tx1"/>
                 </a:solidFill>
               </a:rPr>
               <a:t> like MUSIC</a:t>
             </a:r>
-            <a:endParaRPr lang="de-DE" sz="1400" dirty="0">
+          </a:p>
+          <a:p>
+            <a:pPr marL="342900" indent="-342900">
+              <a:buFont typeface="+mj-lt"/>
+              <a:buAutoNum type="arabicPeriod"/>
+            </a:pPr>
+            <a:r>
+              <a:rPr lang="de-DE" sz="1400" strike="sngStrike" dirty="0" err="1">
+                <a:solidFill>
+                  <a:schemeClr val="tx1"/>
+                </a:solidFill>
+              </a:rPr>
+              <a:t>add</a:t>
+            </a:r>
+            <a:r>
+              <a:rPr lang="de-DE" sz="1400" strike="sngStrike" dirty="0">
+                <a:solidFill>
+                  <a:schemeClr val="tx1"/>
+                </a:solidFill>
+              </a:rPr>
+              <a:t> </a:t>
+            </a:r>
+            <a:r>
+              <a:rPr lang="de-DE" sz="1400" strike="sngStrike" dirty="0" err="1">
+                <a:solidFill>
+                  <a:schemeClr val="tx1"/>
+                </a:solidFill>
+              </a:rPr>
+              <a:t>set</a:t>
+            </a:r>
+            <a:r>
+              <a:rPr lang="de-DE" sz="1400" strike="sngStrike" dirty="0">
+                <a:solidFill>
+                  <a:schemeClr val="tx1"/>
+                </a:solidFill>
+              </a:rPr>
+              <a:t> </a:t>
+            </a:r>
+            <a:r>
+              <a:rPr lang="de-DE" sz="1400" strike="sngStrike" dirty="0" err="1">
+                <a:solidFill>
+                  <a:schemeClr val="tx1"/>
+                </a:solidFill>
+              </a:rPr>
+              <a:t>button</a:t>
+            </a:r>
+            <a:r>
+              <a:rPr lang="de-DE" sz="1400" strike="sngStrike" dirty="0">
+                <a:solidFill>
+                  <a:schemeClr val="tx1"/>
+                </a:solidFill>
+              </a:rPr>
+              <a:t> </a:t>
+            </a:r>
+            <a:r>
+              <a:rPr lang="de-DE" sz="1400" strike="sngStrike" dirty="0" err="1">
+                <a:solidFill>
+                  <a:schemeClr val="tx1"/>
+                </a:solidFill>
+              </a:rPr>
+              <a:t>for</a:t>
+            </a:r>
+            <a:r>
+              <a:rPr lang="de-DE" sz="1400" strike="sngStrike" dirty="0">
+                <a:solidFill>
+                  <a:schemeClr val="tx1"/>
+                </a:solidFill>
+              </a:rPr>
+              <a:t> </a:t>
+            </a:r>
+            <a:r>
+              <a:rPr lang="de-DE" sz="1400" strike="sngStrike" dirty="0" err="1">
+                <a:solidFill>
+                  <a:schemeClr val="tx1"/>
+                </a:solidFill>
+              </a:rPr>
+              <a:t>scifi</a:t>
+            </a:r>
+            <a:r>
+              <a:rPr lang="de-DE" sz="1400" strike="sngStrike" dirty="0">
+                <a:solidFill>
+                  <a:schemeClr val="tx1"/>
+                </a:solidFill>
+              </a:rPr>
+              <a:t> </a:t>
+            </a:r>
+            <a:r>
+              <a:rPr lang="de-DE" sz="1400" strike="sngStrike" dirty="0" err="1">
+                <a:solidFill>
+                  <a:schemeClr val="tx1"/>
+                </a:solidFill>
+              </a:rPr>
+              <a:t>bias</a:t>
+            </a:r>
+            <a:r>
+              <a:rPr lang="de-DE" sz="1400" strike="sngStrike" dirty="0">
+                <a:solidFill>
+                  <a:schemeClr val="tx1"/>
+                </a:solidFill>
+              </a:rPr>
+              <a:t> </a:t>
+            </a:r>
+            <a:r>
+              <a:rPr lang="de-DE" sz="1400" strike="sngStrike" dirty="0" err="1">
+                <a:solidFill>
+                  <a:schemeClr val="tx1"/>
+                </a:solidFill>
+              </a:rPr>
+              <a:t>set</a:t>
+            </a:r>
+            <a:endParaRPr lang="de-DE" sz="1400" strike="sngStrike" dirty="0">
               <a:solidFill>
                 <a:schemeClr val="tx1"/>
               </a:solidFill>

</xml_diff>

<commit_message>
Configuration files and python scripts
</commit_message>
<xml_diff>
--- a/CSS_examples/Documentation && Report/CSS works.pptx
+++ b/CSS_examples/Documentation && Report/CSS works.pptx
@@ -5,10 +5,10 @@
     <p:sldMasterId id="2147483648" r:id="rId1"/>
   </p:sldMasterIdLst>
   <p:notesMasterIdLst>
-    <p:notesMasterId r:id="rId21"/>
+    <p:notesMasterId r:id="rId23"/>
   </p:notesMasterIdLst>
   <p:handoutMasterIdLst>
-    <p:handoutMasterId r:id="rId22"/>
+    <p:handoutMasterId r:id="rId24"/>
   </p:handoutMasterIdLst>
   <p:sldIdLst>
     <p:sldId id="256" r:id="rId2"/>
@@ -30,6 +30,8 @@
     <p:sldId id="272" r:id="rId18"/>
     <p:sldId id="273" r:id="rId19"/>
     <p:sldId id="274" r:id="rId20"/>
+    <p:sldId id="275" r:id="rId21"/>
+    <p:sldId id="276" r:id="rId22"/>
   </p:sldIdLst>
   <p:sldSz cx="9144000" cy="5143500" type="screen16x9"/>
   <p:notesSz cx="7104063" cy="10234613"/>
@@ -229,7 +231,7 @@
           <a:p>
             <a:fld id="{0B851660-0934-124D-A4B3-496C7F320307}" type="datetimeFigureOut">
               <a:rPr lang="de-DE" smtClean="0"/>
-              <a:t>24.08.2026</a:t>
+              <a:t>25.08.2026</a:t>
             </a:fld>
             <a:endParaRPr lang="de-DE"/>
           </a:p>
@@ -395,7 +397,7 @@
           <a:p>
             <a:fld id="{98C828EF-C252-394A-93BF-1C478CFA0896}" type="datetimeFigureOut">
               <a:rPr lang="de-DE" smtClean="0"/>
-              <a:t>24.08.2026</a:t>
+              <a:t>25.08.2026</a:t>
             </a:fld>
             <a:endParaRPr lang="de-DE"/>
           </a:p>
@@ -8374,6 +8376,1705 @@
     <p:extLst>
       <p:ext uri="{BB962C8B-B14F-4D97-AF65-F5344CB8AC3E}">
         <p14:creationId xmlns:p14="http://schemas.microsoft.com/office/powerpoint/2010/main" val="386579042"/>
+      </p:ext>
+    </p:extLst>
+  </p:cSld>
+  <p:clrMapOvr>
+    <a:masterClrMapping/>
+  </p:clrMapOvr>
+</p:sld>
+</file>
+
+<file path=ppt/slides/slide20.xml><?xml version="1.0" encoding="utf-8"?>
+<p:sld xmlns:a="http://schemas.openxmlformats.org/drawingml/2006/main" xmlns:r="http://schemas.openxmlformats.org/officeDocument/2006/relationships" xmlns:p="http://schemas.openxmlformats.org/presentationml/2006/main">
+  <p:cSld>
+    <p:spTree>
+      <p:nvGrpSpPr>
+        <p:cNvPr id="1" name=""/>
+        <p:cNvGrpSpPr/>
+        <p:nvPr/>
+      </p:nvGrpSpPr>
+      <p:grpSpPr>
+        <a:xfrm>
+          <a:off x="0" y="0"/>
+          <a:ext cx="0" cy="0"/>
+          <a:chOff x="0" y="0"/>
+          <a:chExt cx="0" cy="0"/>
+        </a:xfrm>
+      </p:grpSpPr>
+      <p:sp>
+        <p:nvSpPr>
+          <p:cNvPr id="2" name="Title 1">
+            <a:extLst>
+              <a:ext uri="{FF2B5EF4-FFF2-40B4-BE49-F238E27FC236}">
+                <a16:creationId xmlns:a16="http://schemas.microsoft.com/office/drawing/2014/main" id="{C4F020AE-CD6F-4C87-8B44-2242F3095430}"/>
+              </a:ext>
+            </a:extLst>
+          </p:cNvPr>
+          <p:cNvSpPr>
+            <a:spLocks noGrp="1"/>
+          </p:cNvSpPr>
+          <p:nvPr>
+            <p:ph type="title"/>
+          </p:nvPr>
+        </p:nvSpPr>
+        <p:spPr/>
+        <p:txBody>
+          <a:bodyPr/>
+          <a:lstStyle/>
+          <a:p>
+            <a:r>
+              <a:rPr lang="de-DE" dirty="0"/>
+              <a:t>Report 26.08.25</a:t>
+            </a:r>
+          </a:p>
+        </p:txBody>
+      </p:sp>
+      <p:sp>
+        <p:nvSpPr>
+          <p:cNvPr id="4" name="Content Placeholder 2">
+            <a:extLst>
+              <a:ext uri="{FF2B5EF4-FFF2-40B4-BE49-F238E27FC236}">
+                <a16:creationId xmlns:a16="http://schemas.microsoft.com/office/drawing/2014/main" id="{FA77772D-0DBC-49CF-A5F5-2F8530CE8539}"/>
+              </a:ext>
+            </a:extLst>
+          </p:cNvPr>
+          <p:cNvSpPr>
+            <a:spLocks noGrp="1"/>
+          </p:cNvSpPr>
+          <p:nvPr>
+            <p:ph idx="1"/>
+          </p:nvPr>
+        </p:nvSpPr>
+        <p:spPr>
+          <a:xfrm>
+            <a:off x="317500" y="1087438"/>
+            <a:ext cx="8420100" cy="3678237"/>
+          </a:xfrm>
+        </p:spPr>
+        <p:txBody>
+          <a:bodyPr/>
+          <a:lstStyle/>
+          <a:p>
+            <a:pPr marL="0" indent="0">
+              <a:buNone/>
+            </a:pPr>
+            <a:r>
+              <a:rPr lang="de-DE" b="1" dirty="0" err="1"/>
+              <a:t>Suggested</a:t>
+            </a:r>
+            <a:endParaRPr lang="de-DE" b="1" dirty="0"/>
+          </a:p>
+          <a:p>
+            <a:pPr marL="342900" indent="-342900">
+              <a:buFont typeface="+mj-lt"/>
+              <a:buAutoNum type="arabicPeriod"/>
+            </a:pPr>
+            <a:r>
+              <a:rPr lang="de-DE" sz="1400" dirty="0" err="1"/>
+              <a:t>to</a:t>
+            </a:r>
+            <a:r>
+              <a:rPr lang="de-DE" sz="1400" dirty="0"/>
+              <a:t> </a:t>
+            </a:r>
+            <a:r>
+              <a:rPr lang="de-DE" sz="1400" dirty="0" err="1"/>
+              <a:t>think</a:t>
+            </a:r>
+            <a:r>
+              <a:rPr lang="de-DE" sz="1400" dirty="0"/>
+              <a:t> </a:t>
+            </a:r>
+            <a:r>
+              <a:rPr lang="de-DE" sz="1400" dirty="0" err="1"/>
+              <a:t>click</a:t>
+            </a:r>
+            <a:r>
+              <a:rPr lang="de-DE" sz="1400" dirty="0"/>
+              <a:t> a </a:t>
+            </a:r>
+            <a:r>
+              <a:rPr lang="de-DE" sz="1400" dirty="0" err="1"/>
+              <a:t>button</a:t>
+            </a:r>
+            <a:r>
+              <a:rPr lang="de-DE" sz="1400" dirty="0"/>
+              <a:t> </a:t>
+            </a:r>
+            <a:r>
+              <a:rPr lang="de-DE" sz="1400" dirty="0" err="1"/>
+              <a:t>to</a:t>
+            </a:r>
+            <a:r>
+              <a:rPr lang="de-DE" sz="1400" dirty="0"/>
+              <a:t> open a </a:t>
+            </a:r>
+            <a:r>
+              <a:rPr lang="de-DE" sz="1400" dirty="0" err="1"/>
+              <a:t>new</a:t>
+            </a:r>
+            <a:r>
+              <a:rPr lang="de-DE" sz="1400" dirty="0"/>
+              <a:t> </a:t>
+            </a:r>
+            <a:r>
+              <a:rPr lang="de-DE" sz="1400" dirty="0" err="1"/>
+              <a:t>tab</a:t>
+            </a:r>
+            <a:endParaRPr lang="de-DE" sz="1400" dirty="0"/>
+          </a:p>
+          <a:p>
+            <a:pPr marL="342900" indent="-342900">
+              <a:buFont typeface="+mj-lt"/>
+              <a:buAutoNum type="arabicPeriod"/>
+            </a:pPr>
+            <a:r>
+              <a:rPr lang="de-DE" sz="1400" dirty="0" err="1">
+                <a:solidFill>
+                  <a:schemeClr val="tx1"/>
+                </a:solidFill>
+              </a:rPr>
+              <a:t>there</a:t>
+            </a:r>
+            <a:r>
+              <a:rPr lang="de-DE" sz="1400" dirty="0">
+                <a:solidFill>
+                  <a:schemeClr val="tx1"/>
+                </a:solidFill>
+              </a:rPr>
+              <a:t> will </a:t>
+            </a:r>
+            <a:r>
+              <a:rPr lang="de-DE" sz="1400" dirty="0" err="1">
+                <a:solidFill>
+                  <a:schemeClr val="tx1"/>
+                </a:solidFill>
+              </a:rPr>
+              <a:t>come</a:t>
+            </a:r>
+            <a:r>
+              <a:rPr lang="de-DE" sz="1400" dirty="0">
+                <a:solidFill>
+                  <a:schemeClr val="tx1"/>
+                </a:solidFill>
+              </a:rPr>
+              <a:t> </a:t>
+            </a:r>
+            <a:r>
+              <a:rPr lang="de-DE" sz="1400" dirty="0" err="1">
+                <a:solidFill>
+                  <a:schemeClr val="tx1"/>
+                </a:solidFill>
+              </a:rPr>
+              <a:t>one</a:t>
+            </a:r>
+            <a:r>
+              <a:rPr lang="de-DE" sz="1400" dirty="0">
+                <a:solidFill>
+                  <a:schemeClr val="tx1"/>
+                </a:solidFill>
+              </a:rPr>
+              <a:t> </a:t>
+            </a:r>
+            <a:r>
+              <a:rPr lang="de-DE" sz="1400" dirty="0" err="1">
+                <a:solidFill>
+                  <a:schemeClr val="tx1"/>
+                </a:solidFill>
+              </a:rPr>
+              <a:t>more</a:t>
+            </a:r>
+            <a:r>
+              <a:rPr lang="de-DE" sz="1400" dirty="0">
+                <a:solidFill>
+                  <a:schemeClr val="tx1"/>
+                </a:solidFill>
+              </a:rPr>
+              <a:t> HV </a:t>
+            </a:r>
+            <a:r>
+              <a:rPr lang="de-DE" sz="1400" dirty="0" err="1">
+                <a:solidFill>
+                  <a:schemeClr val="tx1"/>
+                </a:solidFill>
+              </a:rPr>
+              <a:t>for</a:t>
+            </a:r>
+            <a:r>
+              <a:rPr lang="de-DE" sz="1400" dirty="0">
+                <a:solidFill>
+                  <a:schemeClr val="tx1"/>
+                </a:solidFill>
+              </a:rPr>
+              <a:t> </a:t>
+            </a:r>
+            <a:r>
+              <a:rPr lang="de-DE" sz="1400" dirty="0" err="1">
+                <a:solidFill>
+                  <a:schemeClr val="tx1"/>
+                </a:solidFill>
+              </a:rPr>
+              <a:t>pos</a:t>
+            </a:r>
+            <a:r>
+              <a:rPr lang="de-DE" sz="1400" dirty="0">
+                <a:solidFill>
+                  <a:schemeClr val="tx1"/>
+                </a:solidFill>
+              </a:rPr>
+              <a:t> </a:t>
+            </a:r>
+            <a:r>
+              <a:rPr lang="de-DE" sz="1400" dirty="0" err="1">
+                <a:solidFill>
+                  <a:schemeClr val="tx1"/>
+                </a:solidFill>
+              </a:rPr>
+              <a:t>values</a:t>
+            </a:r>
+            <a:endParaRPr lang="de-DE" sz="1400" dirty="0">
+              <a:solidFill>
+                <a:schemeClr val="tx1"/>
+              </a:solidFill>
+            </a:endParaRPr>
+          </a:p>
+          <a:p>
+            <a:pPr marL="342900" indent="-342900">
+              <a:buFont typeface="+mj-lt"/>
+              <a:buAutoNum type="arabicPeriod"/>
+            </a:pPr>
+            <a:r>
+              <a:rPr lang="de-DE" sz="1400" dirty="0" err="1">
+                <a:solidFill>
+                  <a:schemeClr val="tx1"/>
+                </a:solidFill>
+              </a:rPr>
+              <a:t>make</a:t>
+            </a:r>
+            <a:r>
+              <a:rPr lang="de-DE" sz="1400" dirty="0">
+                <a:solidFill>
+                  <a:schemeClr val="tx1"/>
+                </a:solidFill>
+              </a:rPr>
+              <a:t> </a:t>
+            </a:r>
+            <a:r>
+              <a:rPr lang="de-DE" sz="1400" dirty="0" err="1">
+                <a:solidFill>
+                  <a:schemeClr val="tx1"/>
+                </a:solidFill>
+              </a:rPr>
+              <a:t>settings</a:t>
+            </a:r>
+            <a:r>
+              <a:rPr lang="de-DE" sz="1400" dirty="0">
+                <a:solidFill>
+                  <a:schemeClr val="tx1"/>
+                </a:solidFill>
+              </a:rPr>
+              <a:t> </a:t>
+            </a:r>
+            <a:r>
+              <a:rPr lang="de-DE" sz="1400" dirty="0" err="1">
+                <a:solidFill>
+                  <a:schemeClr val="tx1"/>
+                </a:solidFill>
+              </a:rPr>
+              <a:t>file</a:t>
+            </a:r>
+            <a:r>
+              <a:rPr lang="de-DE" sz="1400" dirty="0">
+                <a:solidFill>
+                  <a:schemeClr val="tx1"/>
+                </a:solidFill>
+              </a:rPr>
+              <a:t> </a:t>
+            </a:r>
+            <a:r>
+              <a:rPr lang="de-DE" sz="1400" dirty="0" err="1">
+                <a:solidFill>
+                  <a:schemeClr val="tx1"/>
+                </a:solidFill>
+              </a:rPr>
+              <a:t>that</a:t>
+            </a:r>
+            <a:r>
+              <a:rPr lang="de-DE" sz="1400" dirty="0">
+                <a:solidFill>
+                  <a:schemeClr val="tx1"/>
+                </a:solidFill>
+              </a:rPr>
+              <a:t> will </a:t>
+            </a:r>
+            <a:r>
+              <a:rPr lang="de-DE" sz="1400" dirty="0" err="1">
+                <a:solidFill>
+                  <a:schemeClr val="tx1"/>
+                </a:solidFill>
+              </a:rPr>
+              <a:t>be</a:t>
+            </a:r>
+            <a:r>
+              <a:rPr lang="de-DE" sz="1400" dirty="0">
+                <a:solidFill>
+                  <a:schemeClr val="tx1"/>
+                </a:solidFill>
+              </a:rPr>
+              <a:t> </a:t>
+            </a:r>
+            <a:r>
+              <a:rPr lang="de-DE" sz="1400" dirty="0" err="1">
+                <a:solidFill>
+                  <a:schemeClr val="tx1"/>
+                </a:solidFill>
+              </a:rPr>
+              <a:t>automatized</a:t>
+            </a:r>
+            <a:r>
+              <a:rPr lang="de-DE" sz="1400" dirty="0">
+                <a:solidFill>
+                  <a:schemeClr val="tx1"/>
+                </a:solidFill>
+              </a:rPr>
+              <a:t> </a:t>
+            </a:r>
+            <a:r>
+              <a:rPr lang="de-DE" sz="1400" dirty="0" err="1">
+                <a:solidFill>
+                  <a:schemeClr val="tx1"/>
+                </a:solidFill>
+              </a:rPr>
+              <a:t>later</a:t>
+            </a:r>
+            <a:r>
+              <a:rPr lang="de-DE" sz="1400" dirty="0">
+                <a:solidFill>
+                  <a:schemeClr val="tx1"/>
+                </a:solidFill>
+              </a:rPr>
+              <a:t> </a:t>
+            </a:r>
+            <a:r>
+              <a:rPr lang="de-DE" sz="1400" dirty="0" err="1">
+                <a:solidFill>
+                  <a:schemeClr val="tx1"/>
+                </a:solidFill>
+              </a:rPr>
+              <a:t>when</a:t>
+            </a:r>
+            <a:r>
+              <a:rPr lang="de-DE" sz="1400" dirty="0">
+                <a:solidFill>
+                  <a:schemeClr val="tx1"/>
+                </a:solidFill>
+              </a:rPr>
+              <a:t> </a:t>
+            </a:r>
+            <a:r>
+              <a:rPr lang="de-DE" sz="1400" dirty="0" err="1">
+                <a:solidFill>
+                  <a:schemeClr val="tx1"/>
+                </a:solidFill>
+              </a:rPr>
+              <a:t>we</a:t>
+            </a:r>
+            <a:r>
+              <a:rPr lang="de-DE" sz="1400" dirty="0">
+                <a:solidFill>
+                  <a:schemeClr val="tx1"/>
+                </a:solidFill>
+              </a:rPr>
+              <a:t> </a:t>
+            </a:r>
+            <a:r>
+              <a:rPr lang="de-DE" sz="1400" dirty="0" err="1">
+                <a:solidFill>
+                  <a:schemeClr val="tx1"/>
+                </a:solidFill>
+              </a:rPr>
+              <a:t>have</a:t>
+            </a:r>
+            <a:r>
+              <a:rPr lang="de-DE" sz="1400" dirty="0">
+                <a:solidFill>
+                  <a:schemeClr val="tx1"/>
+                </a:solidFill>
+              </a:rPr>
+              <a:t> different </a:t>
+            </a:r>
+            <a:r>
+              <a:rPr lang="de-DE" sz="1400" dirty="0" err="1">
+                <a:solidFill>
+                  <a:schemeClr val="tx1"/>
+                </a:solidFill>
+              </a:rPr>
+              <a:t>layout</a:t>
+            </a:r>
+            <a:r>
+              <a:rPr lang="de-DE" sz="1400" dirty="0">
+                <a:solidFill>
+                  <a:schemeClr val="tx1"/>
+                </a:solidFill>
+              </a:rPr>
+              <a:t> </a:t>
+            </a:r>
+            <a:r>
+              <a:rPr lang="de-DE" sz="1400" dirty="0" err="1">
+                <a:solidFill>
+                  <a:schemeClr val="tx1"/>
+                </a:solidFill>
+              </a:rPr>
+              <a:t>ideas</a:t>
+            </a:r>
+            <a:endParaRPr lang="de-DE" sz="1400" dirty="0">
+              <a:solidFill>
+                <a:schemeClr val="tx1"/>
+              </a:solidFill>
+            </a:endParaRPr>
+          </a:p>
+          <a:p>
+            <a:pPr marL="342900" indent="-342900">
+              <a:buFont typeface="+mj-lt"/>
+              <a:buAutoNum type="arabicPeriod"/>
+            </a:pPr>
+            <a:r>
+              <a:rPr lang="de-DE" sz="1400" strike="sngStrike" dirty="0" err="1">
+                <a:solidFill>
+                  <a:schemeClr val="tx1"/>
+                </a:solidFill>
+              </a:rPr>
+              <a:t>naming</a:t>
+            </a:r>
+            <a:r>
+              <a:rPr lang="de-DE" sz="1400" strike="sngStrike" dirty="0">
+                <a:solidFill>
+                  <a:schemeClr val="tx1"/>
+                </a:solidFill>
+              </a:rPr>
+              <a:t> and README </a:t>
+            </a:r>
+            <a:r>
+              <a:rPr lang="de-DE" sz="1400" strike="sngStrike" dirty="0" err="1">
+                <a:solidFill>
+                  <a:schemeClr val="tx1"/>
+                </a:solidFill>
+              </a:rPr>
+              <a:t>files</a:t>
+            </a:r>
+            <a:r>
+              <a:rPr lang="de-DE" sz="1400" strike="sngStrike" dirty="0">
+                <a:solidFill>
+                  <a:schemeClr val="tx1"/>
+                </a:solidFill>
+              </a:rPr>
+              <a:t> </a:t>
+            </a:r>
+            <a:r>
+              <a:rPr lang="de-DE" sz="1400" strike="sngStrike" dirty="0" err="1">
+                <a:solidFill>
+                  <a:schemeClr val="tx1"/>
+                </a:solidFill>
+              </a:rPr>
+              <a:t>should</a:t>
+            </a:r>
+            <a:r>
+              <a:rPr lang="de-DE" sz="1400" strike="sngStrike" dirty="0">
+                <a:solidFill>
+                  <a:schemeClr val="tx1"/>
+                </a:solidFill>
+              </a:rPr>
+              <a:t> </a:t>
+            </a:r>
+            <a:r>
+              <a:rPr lang="de-DE" sz="1400" strike="sngStrike" dirty="0" err="1">
+                <a:solidFill>
+                  <a:schemeClr val="tx1"/>
+                </a:solidFill>
+              </a:rPr>
+              <a:t>be</a:t>
+            </a:r>
+            <a:r>
+              <a:rPr lang="de-DE" sz="1400" strike="sngStrike" dirty="0">
+                <a:solidFill>
+                  <a:schemeClr val="tx1"/>
+                </a:solidFill>
+              </a:rPr>
+              <a:t> </a:t>
+            </a:r>
+            <a:r>
+              <a:rPr lang="de-DE" sz="1400" strike="sngStrike" dirty="0" err="1">
+                <a:solidFill>
+                  <a:schemeClr val="tx1"/>
+                </a:solidFill>
+              </a:rPr>
+              <a:t>done</a:t>
+            </a:r>
+            <a:r>
+              <a:rPr lang="de-DE" sz="1400" strike="sngStrike" dirty="0">
+                <a:solidFill>
+                  <a:schemeClr val="tx1"/>
+                </a:solidFill>
+              </a:rPr>
+              <a:t> like MUSIC</a:t>
+            </a:r>
+          </a:p>
+          <a:p>
+            <a:pPr marL="342900" indent="-342900">
+              <a:buFont typeface="+mj-lt"/>
+              <a:buAutoNum type="arabicPeriod"/>
+            </a:pPr>
+            <a:r>
+              <a:rPr lang="de-DE" sz="1400" strike="sngStrike" dirty="0" err="1">
+                <a:solidFill>
+                  <a:schemeClr val="tx1"/>
+                </a:solidFill>
+              </a:rPr>
+              <a:t>add</a:t>
+            </a:r>
+            <a:r>
+              <a:rPr lang="de-DE" sz="1400" strike="sngStrike" dirty="0">
+                <a:solidFill>
+                  <a:schemeClr val="tx1"/>
+                </a:solidFill>
+              </a:rPr>
+              <a:t> </a:t>
+            </a:r>
+            <a:r>
+              <a:rPr lang="de-DE" sz="1400" strike="sngStrike" dirty="0" err="1">
+                <a:solidFill>
+                  <a:schemeClr val="tx1"/>
+                </a:solidFill>
+              </a:rPr>
+              <a:t>set</a:t>
+            </a:r>
+            <a:r>
+              <a:rPr lang="de-DE" sz="1400" strike="sngStrike" dirty="0">
+                <a:solidFill>
+                  <a:schemeClr val="tx1"/>
+                </a:solidFill>
+              </a:rPr>
+              <a:t> </a:t>
+            </a:r>
+            <a:r>
+              <a:rPr lang="de-DE" sz="1400" strike="sngStrike" dirty="0" err="1">
+                <a:solidFill>
+                  <a:schemeClr val="tx1"/>
+                </a:solidFill>
+              </a:rPr>
+              <a:t>button</a:t>
+            </a:r>
+            <a:r>
+              <a:rPr lang="de-DE" sz="1400" strike="sngStrike" dirty="0">
+                <a:solidFill>
+                  <a:schemeClr val="tx1"/>
+                </a:solidFill>
+              </a:rPr>
+              <a:t> </a:t>
+            </a:r>
+            <a:r>
+              <a:rPr lang="de-DE" sz="1400" strike="sngStrike" dirty="0" err="1">
+                <a:solidFill>
+                  <a:schemeClr val="tx1"/>
+                </a:solidFill>
+              </a:rPr>
+              <a:t>for</a:t>
+            </a:r>
+            <a:r>
+              <a:rPr lang="de-DE" sz="1400" strike="sngStrike" dirty="0">
+                <a:solidFill>
+                  <a:schemeClr val="tx1"/>
+                </a:solidFill>
+              </a:rPr>
+              <a:t> </a:t>
+            </a:r>
+            <a:r>
+              <a:rPr lang="de-DE" sz="1400" strike="sngStrike" dirty="0" err="1">
+                <a:solidFill>
+                  <a:schemeClr val="tx1"/>
+                </a:solidFill>
+              </a:rPr>
+              <a:t>scifi</a:t>
+            </a:r>
+            <a:r>
+              <a:rPr lang="de-DE" sz="1400" strike="sngStrike" dirty="0">
+                <a:solidFill>
+                  <a:schemeClr val="tx1"/>
+                </a:solidFill>
+              </a:rPr>
+              <a:t> </a:t>
+            </a:r>
+            <a:r>
+              <a:rPr lang="de-DE" sz="1400" strike="sngStrike" dirty="0" err="1">
+                <a:solidFill>
+                  <a:schemeClr val="tx1"/>
+                </a:solidFill>
+              </a:rPr>
+              <a:t>bias</a:t>
+            </a:r>
+            <a:r>
+              <a:rPr lang="de-DE" sz="1400" strike="sngStrike" dirty="0">
+                <a:solidFill>
+                  <a:schemeClr val="tx1"/>
+                </a:solidFill>
+              </a:rPr>
+              <a:t> </a:t>
+            </a:r>
+            <a:r>
+              <a:rPr lang="de-DE" sz="1400" strike="sngStrike" dirty="0" err="1">
+                <a:solidFill>
+                  <a:schemeClr val="tx1"/>
+                </a:solidFill>
+              </a:rPr>
+              <a:t>set</a:t>
+            </a:r>
+            <a:endParaRPr lang="de-DE" sz="1400" strike="sngStrike" dirty="0">
+              <a:solidFill>
+                <a:schemeClr val="tx1"/>
+              </a:solidFill>
+            </a:endParaRPr>
+          </a:p>
+          <a:p>
+            <a:pPr marL="342900" indent="-342900">
+              <a:buFont typeface="+mj-lt"/>
+              <a:buAutoNum type="arabicPeriod"/>
+            </a:pPr>
+            <a:endParaRPr lang="de-DE" sz="1400" dirty="0"/>
+          </a:p>
+          <a:p>
+            <a:pPr marL="0" indent="0">
+              <a:buNone/>
+            </a:pPr>
+            <a:r>
+              <a:rPr lang="de-DE" b="1" dirty="0"/>
+              <a:t>Questions / </a:t>
+            </a:r>
+            <a:r>
+              <a:rPr lang="de-DE" b="1" dirty="0" err="1"/>
+              <a:t>Ideas</a:t>
+            </a:r>
+            <a:endParaRPr lang="de-DE" b="1" dirty="0"/>
+          </a:p>
+          <a:p>
+            <a:pPr marL="342900" indent="-342900">
+              <a:buFont typeface="+mj-lt"/>
+              <a:buAutoNum type="arabicPeriod"/>
+            </a:pPr>
+            <a:r>
+              <a:rPr lang="de-DE" sz="1400" dirty="0" err="1"/>
+              <a:t>multistate</a:t>
+            </a:r>
+            <a:r>
+              <a:rPr lang="de-DE" sz="1400" dirty="0"/>
+              <a:t> </a:t>
+            </a:r>
+            <a:r>
+              <a:rPr lang="de-DE" sz="1400" dirty="0" err="1"/>
+              <a:t>leds</a:t>
+            </a:r>
+            <a:r>
+              <a:rPr lang="de-DE" sz="1400" dirty="0"/>
+              <a:t> </a:t>
+            </a:r>
+            <a:r>
+              <a:rPr lang="de-DE" sz="1400" dirty="0" err="1"/>
+              <a:t>make</a:t>
+            </a:r>
+            <a:r>
+              <a:rPr lang="de-DE" sz="1400" dirty="0"/>
+              <a:t> </a:t>
+            </a:r>
+            <a:r>
+              <a:rPr lang="de-DE" sz="1400" dirty="0" err="1"/>
+              <a:t>error</a:t>
+            </a:r>
+            <a:r>
+              <a:rPr lang="de-DE" sz="1400" dirty="0"/>
+              <a:t>, </a:t>
+            </a:r>
+            <a:r>
+              <a:rPr lang="de-DE" sz="1400" dirty="0" err="1"/>
+              <a:t>warning</a:t>
+            </a:r>
+            <a:r>
+              <a:rPr lang="de-DE" sz="1400" dirty="0"/>
+              <a:t>, ok</a:t>
+            </a:r>
+          </a:p>
+          <a:p>
+            <a:pPr marL="342900" indent="-342900">
+              <a:buFont typeface="+mj-lt"/>
+              <a:buAutoNum type="arabicPeriod"/>
+            </a:pPr>
+            <a:r>
+              <a:rPr lang="de-DE" sz="1400" dirty="0" err="1"/>
+              <a:t>for</a:t>
+            </a:r>
+            <a:r>
+              <a:rPr lang="de-DE" sz="1400" dirty="0"/>
+              <a:t> </a:t>
+            </a:r>
+            <a:r>
+              <a:rPr lang="de-DE" sz="1400" dirty="0" err="1"/>
+              <a:t>plsci</a:t>
+            </a:r>
+            <a:r>
+              <a:rPr lang="de-DE" sz="1400" dirty="0"/>
+              <a:t> </a:t>
+            </a:r>
+            <a:r>
+              <a:rPr lang="de-DE" sz="1400" dirty="0" err="1"/>
+              <a:t>it</a:t>
+            </a:r>
+            <a:r>
+              <a:rPr lang="de-DE" sz="1400" dirty="0"/>
+              <a:t> </a:t>
+            </a:r>
+            <a:r>
+              <a:rPr lang="de-DE" sz="1400" dirty="0" err="1"/>
+              <a:t>may</a:t>
+            </a:r>
+            <a:r>
+              <a:rPr lang="de-DE" sz="1400" dirty="0"/>
+              <a:t> </a:t>
+            </a:r>
+            <a:r>
+              <a:rPr lang="de-DE" sz="1400" dirty="0" err="1"/>
+              <a:t>be</a:t>
+            </a:r>
+            <a:r>
+              <a:rPr lang="de-DE" sz="1400" dirty="0"/>
+              <a:t> </a:t>
+            </a:r>
+            <a:r>
+              <a:rPr lang="de-DE" sz="1400" dirty="0" err="1"/>
+              <a:t>used</a:t>
+            </a:r>
+            <a:r>
+              <a:rPr lang="de-DE" sz="1400" dirty="0"/>
+              <a:t> tank/</a:t>
+            </a:r>
+            <a:r>
+              <a:rPr lang="de-DE" sz="1400" dirty="0" err="1"/>
+              <a:t>progress</a:t>
+            </a:r>
+            <a:r>
+              <a:rPr lang="de-DE" sz="1400" dirty="0"/>
+              <a:t> bar </a:t>
+            </a:r>
+            <a:r>
+              <a:rPr lang="de-DE" sz="1400" dirty="0" err="1"/>
+              <a:t>for</a:t>
+            </a:r>
+            <a:r>
+              <a:rPr lang="de-DE" sz="1400" dirty="0"/>
+              <a:t> HV_I_RBV</a:t>
+            </a:r>
+          </a:p>
+          <a:p>
+            <a:pPr marL="300038" lvl="1" indent="0">
+              <a:buNone/>
+            </a:pPr>
+            <a:endParaRPr lang="de-DE" sz="1000" dirty="0"/>
+          </a:p>
+        </p:txBody>
+      </p:sp>
+    </p:spTree>
+    <p:extLst>
+      <p:ext uri="{BB962C8B-B14F-4D97-AF65-F5344CB8AC3E}">
+        <p14:creationId xmlns:p14="http://schemas.microsoft.com/office/powerpoint/2010/main" val="2886139103"/>
+      </p:ext>
+    </p:extLst>
+  </p:cSld>
+  <p:clrMapOvr>
+    <a:masterClrMapping/>
+  </p:clrMapOvr>
+</p:sld>
+</file>
+
+<file path=ppt/slides/slide21.xml><?xml version="1.0" encoding="utf-8"?>
+<p:sld xmlns:a="http://schemas.openxmlformats.org/drawingml/2006/main" xmlns:r="http://schemas.openxmlformats.org/officeDocument/2006/relationships" xmlns:p="http://schemas.openxmlformats.org/presentationml/2006/main">
+  <p:cSld>
+    <p:spTree>
+      <p:nvGrpSpPr>
+        <p:cNvPr id="1" name=""/>
+        <p:cNvGrpSpPr/>
+        <p:nvPr/>
+      </p:nvGrpSpPr>
+      <p:grpSpPr>
+        <a:xfrm>
+          <a:off x="0" y="0"/>
+          <a:ext cx="0" cy="0"/>
+          <a:chOff x="0" y="0"/>
+          <a:chExt cx="0" cy="0"/>
+        </a:xfrm>
+      </p:grpSpPr>
+      <p:sp>
+        <p:nvSpPr>
+          <p:cNvPr id="2" name="Title 1">
+            <a:extLst>
+              <a:ext uri="{FF2B5EF4-FFF2-40B4-BE49-F238E27FC236}">
+                <a16:creationId xmlns:a16="http://schemas.microsoft.com/office/drawing/2014/main" id="{C4F020AE-CD6F-4C87-8B44-2242F3095430}"/>
+              </a:ext>
+            </a:extLst>
+          </p:cNvPr>
+          <p:cNvSpPr>
+            <a:spLocks noGrp="1"/>
+          </p:cNvSpPr>
+          <p:nvPr>
+            <p:ph type="title"/>
+          </p:nvPr>
+        </p:nvSpPr>
+        <p:spPr/>
+        <p:txBody>
+          <a:bodyPr/>
+          <a:lstStyle/>
+          <a:p>
+            <a:r>
+              <a:rPr lang="de-DE" dirty="0"/>
+              <a:t>Report 26.08.26</a:t>
+            </a:r>
+          </a:p>
+        </p:txBody>
+      </p:sp>
+      <p:sp>
+        <p:nvSpPr>
+          <p:cNvPr id="4" name="Content Placeholder 2">
+            <a:extLst>
+              <a:ext uri="{FF2B5EF4-FFF2-40B4-BE49-F238E27FC236}">
+                <a16:creationId xmlns:a16="http://schemas.microsoft.com/office/drawing/2014/main" id="{FA77772D-0DBC-49CF-A5F5-2F8530CE8539}"/>
+              </a:ext>
+            </a:extLst>
+          </p:cNvPr>
+          <p:cNvSpPr>
+            <a:spLocks noGrp="1"/>
+          </p:cNvSpPr>
+          <p:nvPr>
+            <p:ph idx="1"/>
+          </p:nvPr>
+        </p:nvSpPr>
+        <p:spPr>
+          <a:xfrm>
+            <a:off x="317500" y="1087438"/>
+            <a:ext cx="8420100" cy="3678237"/>
+          </a:xfrm>
+        </p:spPr>
+        <p:txBody>
+          <a:bodyPr/>
+          <a:lstStyle/>
+          <a:p>
+            <a:pPr marL="0" indent="0">
+              <a:buNone/>
+            </a:pPr>
+            <a:r>
+              <a:rPr lang="de-DE" b="1" dirty="0" err="1"/>
+              <a:t>Suggested</a:t>
+            </a:r>
+            <a:endParaRPr lang="de-DE" b="1" dirty="0"/>
+          </a:p>
+          <a:p>
+            <a:pPr marL="342900" indent="-342900">
+              <a:buFont typeface="+mj-lt"/>
+              <a:buAutoNum type="arabicPeriod"/>
+            </a:pPr>
+            <a:r>
+              <a:rPr lang="de-DE" sz="1400" dirty="0" err="1"/>
+              <a:t>to</a:t>
+            </a:r>
+            <a:r>
+              <a:rPr lang="de-DE" sz="1400" dirty="0"/>
+              <a:t> </a:t>
+            </a:r>
+            <a:r>
+              <a:rPr lang="de-DE" sz="1400" dirty="0" err="1"/>
+              <a:t>think</a:t>
+            </a:r>
+            <a:r>
+              <a:rPr lang="de-DE" sz="1400" dirty="0"/>
+              <a:t> </a:t>
+            </a:r>
+            <a:r>
+              <a:rPr lang="de-DE" sz="1400" dirty="0" err="1"/>
+              <a:t>click</a:t>
+            </a:r>
+            <a:r>
+              <a:rPr lang="de-DE" sz="1400" dirty="0"/>
+              <a:t> a </a:t>
+            </a:r>
+            <a:r>
+              <a:rPr lang="de-DE" sz="1400" dirty="0" err="1"/>
+              <a:t>button</a:t>
+            </a:r>
+            <a:r>
+              <a:rPr lang="de-DE" sz="1400" dirty="0"/>
+              <a:t> </a:t>
+            </a:r>
+            <a:r>
+              <a:rPr lang="de-DE" sz="1400" dirty="0" err="1"/>
+              <a:t>to</a:t>
+            </a:r>
+            <a:r>
+              <a:rPr lang="de-DE" sz="1400" dirty="0"/>
+              <a:t> open a </a:t>
+            </a:r>
+            <a:r>
+              <a:rPr lang="de-DE" sz="1400" dirty="0" err="1"/>
+              <a:t>new</a:t>
+            </a:r>
+            <a:r>
+              <a:rPr lang="de-DE" sz="1400" dirty="0"/>
+              <a:t> </a:t>
+            </a:r>
+            <a:r>
+              <a:rPr lang="de-DE" sz="1400" dirty="0" err="1"/>
+              <a:t>tab</a:t>
+            </a:r>
+            <a:endParaRPr lang="de-DE" sz="1400" dirty="0"/>
+          </a:p>
+          <a:p>
+            <a:pPr marL="342900" indent="-342900">
+              <a:buFont typeface="+mj-lt"/>
+              <a:buAutoNum type="arabicPeriod"/>
+            </a:pPr>
+            <a:r>
+              <a:rPr lang="de-DE" sz="1400" dirty="0" err="1">
+                <a:solidFill>
+                  <a:schemeClr val="tx1"/>
+                </a:solidFill>
+              </a:rPr>
+              <a:t>there</a:t>
+            </a:r>
+            <a:r>
+              <a:rPr lang="de-DE" sz="1400" dirty="0">
+                <a:solidFill>
+                  <a:schemeClr val="tx1"/>
+                </a:solidFill>
+              </a:rPr>
+              <a:t> will </a:t>
+            </a:r>
+            <a:r>
+              <a:rPr lang="de-DE" sz="1400" dirty="0" err="1">
+                <a:solidFill>
+                  <a:schemeClr val="tx1"/>
+                </a:solidFill>
+              </a:rPr>
+              <a:t>come</a:t>
+            </a:r>
+            <a:r>
+              <a:rPr lang="de-DE" sz="1400" dirty="0">
+                <a:solidFill>
+                  <a:schemeClr val="tx1"/>
+                </a:solidFill>
+              </a:rPr>
+              <a:t> </a:t>
+            </a:r>
+            <a:r>
+              <a:rPr lang="de-DE" sz="1400" dirty="0" err="1">
+                <a:solidFill>
+                  <a:schemeClr val="tx1"/>
+                </a:solidFill>
+              </a:rPr>
+              <a:t>one</a:t>
+            </a:r>
+            <a:r>
+              <a:rPr lang="de-DE" sz="1400" dirty="0">
+                <a:solidFill>
+                  <a:schemeClr val="tx1"/>
+                </a:solidFill>
+              </a:rPr>
+              <a:t> </a:t>
+            </a:r>
+            <a:r>
+              <a:rPr lang="de-DE" sz="1400" dirty="0" err="1">
+                <a:solidFill>
+                  <a:schemeClr val="tx1"/>
+                </a:solidFill>
+              </a:rPr>
+              <a:t>more</a:t>
+            </a:r>
+            <a:r>
+              <a:rPr lang="de-DE" sz="1400" dirty="0">
+                <a:solidFill>
+                  <a:schemeClr val="tx1"/>
+                </a:solidFill>
+              </a:rPr>
+              <a:t> HV </a:t>
+            </a:r>
+            <a:r>
+              <a:rPr lang="de-DE" sz="1400" dirty="0" err="1">
+                <a:solidFill>
+                  <a:schemeClr val="tx1"/>
+                </a:solidFill>
+              </a:rPr>
+              <a:t>for</a:t>
+            </a:r>
+            <a:r>
+              <a:rPr lang="de-DE" sz="1400" dirty="0">
+                <a:solidFill>
+                  <a:schemeClr val="tx1"/>
+                </a:solidFill>
+              </a:rPr>
+              <a:t> </a:t>
+            </a:r>
+            <a:r>
+              <a:rPr lang="de-DE" sz="1400" dirty="0" err="1">
+                <a:solidFill>
+                  <a:schemeClr val="tx1"/>
+                </a:solidFill>
+              </a:rPr>
+              <a:t>pos</a:t>
+            </a:r>
+            <a:r>
+              <a:rPr lang="de-DE" sz="1400" dirty="0">
+                <a:solidFill>
+                  <a:schemeClr val="tx1"/>
+                </a:solidFill>
+              </a:rPr>
+              <a:t> </a:t>
+            </a:r>
+            <a:r>
+              <a:rPr lang="de-DE" sz="1400" dirty="0" err="1">
+                <a:solidFill>
+                  <a:schemeClr val="tx1"/>
+                </a:solidFill>
+              </a:rPr>
+              <a:t>values</a:t>
+            </a:r>
+            <a:endParaRPr lang="de-DE" sz="1400" dirty="0">
+              <a:solidFill>
+                <a:schemeClr val="tx1"/>
+              </a:solidFill>
+            </a:endParaRPr>
+          </a:p>
+          <a:p>
+            <a:pPr marL="342900" indent="-342900">
+              <a:buFont typeface="+mj-lt"/>
+              <a:buAutoNum type="arabicPeriod"/>
+            </a:pPr>
+            <a:r>
+              <a:rPr lang="de-DE" sz="1400" dirty="0" err="1">
+                <a:solidFill>
+                  <a:schemeClr val="tx1"/>
+                </a:solidFill>
+              </a:rPr>
+              <a:t>make</a:t>
+            </a:r>
+            <a:r>
+              <a:rPr lang="de-DE" sz="1400" dirty="0">
+                <a:solidFill>
+                  <a:schemeClr val="tx1"/>
+                </a:solidFill>
+              </a:rPr>
+              <a:t> </a:t>
+            </a:r>
+            <a:r>
+              <a:rPr lang="de-DE" sz="1400" dirty="0" err="1">
+                <a:solidFill>
+                  <a:schemeClr val="tx1"/>
+                </a:solidFill>
+              </a:rPr>
+              <a:t>settings</a:t>
+            </a:r>
+            <a:r>
+              <a:rPr lang="de-DE" sz="1400" dirty="0">
+                <a:solidFill>
+                  <a:schemeClr val="tx1"/>
+                </a:solidFill>
+              </a:rPr>
+              <a:t> </a:t>
+            </a:r>
+            <a:r>
+              <a:rPr lang="de-DE" sz="1400" dirty="0" err="1">
+                <a:solidFill>
+                  <a:schemeClr val="tx1"/>
+                </a:solidFill>
+              </a:rPr>
+              <a:t>file</a:t>
+            </a:r>
+            <a:r>
+              <a:rPr lang="de-DE" sz="1400" dirty="0">
+                <a:solidFill>
+                  <a:schemeClr val="tx1"/>
+                </a:solidFill>
+              </a:rPr>
+              <a:t> </a:t>
+            </a:r>
+            <a:r>
+              <a:rPr lang="de-DE" sz="1400" dirty="0" err="1">
+                <a:solidFill>
+                  <a:schemeClr val="tx1"/>
+                </a:solidFill>
+              </a:rPr>
+              <a:t>that</a:t>
+            </a:r>
+            <a:r>
+              <a:rPr lang="de-DE" sz="1400" dirty="0">
+                <a:solidFill>
+                  <a:schemeClr val="tx1"/>
+                </a:solidFill>
+              </a:rPr>
+              <a:t> will </a:t>
+            </a:r>
+            <a:r>
+              <a:rPr lang="de-DE" sz="1400" dirty="0" err="1">
+                <a:solidFill>
+                  <a:schemeClr val="tx1"/>
+                </a:solidFill>
+              </a:rPr>
+              <a:t>be</a:t>
+            </a:r>
+            <a:r>
+              <a:rPr lang="de-DE" sz="1400" dirty="0">
+                <a:solidFill>
+                  <a:schemeClr val="tx1"/>
+                </a:solidFill>
+              </a:rPr>
+              <a:t> </a:t>
+            </a:r>
+            <a:r>
+              <a:rPr lang="de-DE" sz="1400" dirty="0" err="1">
+                <a:solidFill>
+                  <a:schemeClr val="tx1"/>
+                </a:solidFill>
+              </a:rPr>
+              <a:t>automatized</a:t>
+            </a:r>
+            <a:r>
+              <a:rPr lang="de-DE" sz="1400" dirty="0">
+                <a:solidFill>
+                  <a:schemeClr val="tx1"/>
+                </a:solidFill>
+              </a:rPr>
+              <a:t> </a:t>
+            </a:r>
+            <a:r>
+              <a:rPr lang="de-DE" sz="1400" dirty="0" err="1">
+                <a:solidFill>
+                  <a:schemeClr val="tx1"/>
+                </a:solidFill>
+              </a:rPr>
+              <a:t>later</a:t>
+            </a:r>
+            <a:r>
+              <a:rPr lang="de-DE" sz="1400" dirty="0">
+                <a:solidFill>
+                  <a:schemeClr val="tx1"/>
+                </a:solidFill>
+              </a:rPr>
+              <a:t> </a:t>
+            </a:r>
+            <a:r>
+              <a:rPr lang="de-DE" sz="1400" dirty="0" err="1">
+                <a:solidFill>
+                  <a:schemeClr val="tx1"/>
+                </a:solidFill>
+              </a:rPr>
+              <a:t>when</a:t>
+            </a:r>
+            <a:r>
+              <a:rPr lang="de-DE" sz="1400" dirty="0">
+                <a:solidFill>
+                  <a:schemeClr val="tx1"/>
+                </a:solidFill>
+              </a:rPr>
+              <a:t> </a:t>
+            </a:r>
+            <a:r>
+              <a:rPr lang="de-DE" sz="1400" dirty="0" err="1">
+                <a:solidFill>
+                  <a:schemeClr val="tx1"/>
+                </a:solidFill>
+              </a:rPr>
+              <a:t>we</a:t>
+            </a:r>
+            <a:r>
+              <a:rPr lang="de-DE" sz="1400" dirty="0">
+                <a:solidFill>
+                  <a:schemeClr val="tx1"/>
+                </a:solidFill>
+              </a:rPr>
+              <a:t> </a:t>
+            </a:r>
+            <a:r>
+              <a:rPr lang="de-DE" sz="1400" dirty="0" err="1">
+                <a:solidFill>
+                  <a:schemeClr val="tx1"/>
+                </a:solidFill>
+              </a:rPr>
+              <a:t>have</a:t>
+            </a:r>
+            <a:r>
+              <a:rPr lang="de-DE" sz="1400" dirty="0">
+                <a:solidFill>
+                  <a:schemeClr val="tx1"/>
+                </a:solidFill>
+              </a:rPr>
+              <a:t> different </a:t>
+            </a:r>
+            <a:r>
+              <a:rPr lang="de-DE" sz="1400" dirty="0" err="1">
+                <a:solidFill>
+                  <a:schemeClr val="tx1"/>
+                </a:solidFill>
+              </a:rPr>
+              <a:t>layout</a:t>
+            </a:r>
+            <a:r>
+              <a:rPr lang="de-DE" sz="1400" dirty="0">
+                <a:solidFill>
+                  <a:schemeClr val="tx1"/>
+                </a:solidFill>
+              </a:rPr>
+              <a:t> </a:t>
+            </a:r>
+            <a:r>
+              <a:rPr lang="de-DE" sz="1400" dirty="0" err="1">
+                <a:solidFill>
+                  <a:schemeClr val="tx1"/>
+                </a:solidFill>
+              </a:rPr>
+              <a:t>ideas</a:t>
+            </a:r>
+            <a:endParaRPr lang="de-DE" sz="1400" dirty="0">
+              <a:solidFill>
+                <a:schemeClr val="tx1"/>
+              </a:solidFill>
+            </a:endParaRPr>
+          </a:p>
+          <a:p>
+            <a:pPr marL="342900" indent="-342900">
+              <a:buFont typeface="+mj-lt"/>
+              <a:buAutoNum type="arabicPeriod"/>
+            </a:pPr>
+            <a:r>
+              <a:rPr lang="de-DE" sz="1400" strike="sngStrike" dirty="0" err="1">
+                <a:solidFill>
+                  <a:schemeClr val="tx1"/>
+                </a:solidFill>
+              </a:rPr>
+              <a:t>naming</a:t>
+            </a:r>
+            <a:r>
+              <a:rPr lang="de-DE" sz="1400" strike="sngStrike" dirty="0">
+                <a:solidFill>
+                  <a:schemeClr val="tx1"/>
+                </a:solidFill>
+              </a:rPr>
+              <a:t> and README </a:t>
+            </a:r>
+            <a:r>
+              <a:rPr lang="de-DE" sz="1400" strike="sngStrike" dirty="0" err="1">
+                <a:solidFill>
+                  <a:schemeClr val="tx1"/>
+                </a:solidFill>
+              </a:rPr>
+              <a:t>files</a:t>
+            </a:r>
+            <a:r>
+              <a:rPr lang="de-DE" sz="1400" strike="sngStrike" dirty="0">
+                <a:solidFill>
+                  <a:schemeClr val="tx1"/>
+                </a:solidFill>
+              </a:rPr>
+              <a:t> </a:t>
+            </a:r>
+            <a:r>
+              <a:rPr lang="de-DE" sz="1400" strike="sngStrike" dirty="0" err="1">
+                <a:solidFill>
+                  <a:schemeClr val="tx1"/>
+                </a:solidFill>
+              </a:rPr>
+              <a:t>should</a:t>
+            </a:r>
+            <a:r>
+              <a:rPr lang="de-DE" sz="1400" strike="sngStrike" dirty="0">
+                <a:solidFill>
+                  <a:schemeClr val="tx1"/>
+                </a:solidFill>
+              </a:rPr>
+              <a:t> </a:t>
+            </a:r>
+            <a:r>
+              <a:rPr lang="de-DE" sz="1400" strike="sngStrike" dirty="0" err="1">
+                <a:solidFill>
+                  <a:schemeClr val="tx1"/>
+                </a:solidFill>
+              </a:rPr>
+              <a:t>be</a:t>
+            </a:r>
+            <a:r>
+              <a:rPr lang="de-DE" sz="1400" strike="sngStrike" dirty="0">
+                <a:solidFill>
+                  <a:schemeClr val="tx1"/>
+                </a:solidFill>
+              </a:rPr>
+              <a:t> </a:t>
+            </a:r>
+            <a:r>
+              <a:rPr lang="de-DE" sz="1400" strike="sngStrike" dirty="0" err="1">
+                <a:solidFill>
+                  <a:schemeClr val="tx1"/>
+                </a:solidFill>
+              </a:rPr>
+              <a:t>done</a:t>
+            </a:r>
+            <a:r>
+              <a:rPr lang="de-DE" sz="1400" strike="sngStrike" dirty="0">
+                <a:solidFill>
+                  <a:schemeClr val="tx1"/>
+                </a:solidFill>
+              </a:rPr>
+              <a:t> like MUSIC</a:t>
+            </a:r>
+          </a:p>
+          <a:p>
+            <a:pPr marL="342900" indent="-342900">
+              <a:buFont typeface="+mj-lt"/>
+              <a:buAutoNum type="arabicPeriod"/>
+            </a:pPr>
+            <a:r>
+              <a:rPr lang="de-DE" sz="1400" strike="sngStrike" dirty="0" err="1">
+                <a:solidFill>
+                  <a:schemeClr val="tx1"/>
+                </a:solidFill>
+              </a:rPr>
+              <a:t>add</a:t>
+            </a:r>
+            <a:r>
+              <a:rPr lang="de-DE" sz="1400" strike="sngStrike" dirty="0">
+                <a:solidFill>
+                  <a:schemeClr val="tx1"/>
+                </a:solidFill>
+              </a:rPr>
+              <a:t> </a:t>
+            </a:r>
+            <a:r>
+              <a:rPr lang="de-DE" sz="1400" strike="sngStrike" dirty="0" err="1">
+                <a:solidFill>
+                  <a:schemeClr val="tx1"/>
+                </a:solidFill>
+              </a:rPr>
+              <a:t>set</a:t>
+            </a:r>
+            <a:r>
+              <a:rPr lang="de-DE" sz="1400" strike="sngStrike" dirty="0">
+                <a:solidFill>
+                  <a:schemeClr val="tx1"/>
+                </a:solidFill>
+              </a:rPr>
+              <a:t> </a:t>
+            </a:r>
+            <a:r>
+              <a:rPr lang="de-DE" sz="1400" strike="sngStrike" dirty="0" err="1">
+                <a:solidFill>
+                  <a:schemeClr val="tx1"/>
+                </a:solidFill>
+              </a:rPr>
+              <a:t>button</a:t>
+            </a:r>
+            <a:r>
+              <a:rPr lang="de-DE" sz="1400" strike="sngStrike" dirty="0">
+                <a:solidFill>
+                  <a:schemeClr val="tx1"/>
+                </a:solidFill>
+              </a:rPr>
+              <a:t> </a:t>
+            </a:r>
+            <a:r>
+              <a:rPr lang="de-DE" sz="1400" strike="sngStrike" dirty="0" err="1">
+                <a:solidFill>
+                  <a:schemeClr val="tx1"/>
+                </a:solidFill>
+              </a:rPr>
+              <a:t>for</a:t>
+            </a:r>
+            <a:r>
+              <a:rPr lang="de-DE" sz="1400" strike="sngStrike" dirty="0">
+                <a:solidFill>
+                  <a:schemeClr val="tx1"/>
+                </a:solidFill>
+              </a:rPr>
+              <a:t> </a:t>
+            </a:r>
+            <a:r>
+              <a:rPr lang="de-DE" sz="1400" strike="sngStrike" dirty="0" err="1">
+                <a:solidFill>
+                  <a:schemeClr val="tx1"/>
+                </a:solidFill>
+              </a:rPr>
+              <a:t>scifi</a:t>
+            </a:r>
+            <a:r>
+              <a:rPr lang="de-DE" sz="1400" strike="sngStrike" dirty="0">
+                <a:solidFill>
+                  <a:schemeClr val="tx1"/>
+                </a:solidFill>
+              </a:rPr>
+              <a:t> </a:t>
+            </a:r>
+            <a:r>
+              <a:rPr lang="de-DE" sz="1400" strike="sngStrike" dirty="0" err="1">
+                <a:solidFill>
+                  <a:schemeClr val="tx1"/>
+                </a:solidFill>
+              </a:rPr>
+              <a:t>bias</a:t>
+            </a:r>
+            <a:r>
+              <a:rPr lang="de-DE" sz="1400" strike="sngStrike" dirty="0">
+                <a:solidFill>
+                  <a:schemeClr val="tx1"/>
+                </a:solidFill>
+              </a:rPr>
+              <a:t> </a:t>
+            </a:r>
+            <a:r>
+              <a:rPr lang="de-DE" sz="1400" strike="sngStrike" dirty="0" err="1">
+                <a:solidFill>
+                  <a:schemeClr val="tx1"/>
+                </a:solidFill>
+              </a:rPr>
+              <a:t>set</a:t>
+            </a:r>
+            <a:endParaRPr lang="de-DE" sz="1400" strike="sngStrike" dirty="0">
+              <a:solidFill>
+                <a:schemeClr val="tx1"/>
+              </a:solidFill>
+            </a:endParaRPr>
+          </a:p>
+          <a:p>
+            <a:pPr marL="342900" indent="-342900">
+              <a:buFont typeface="+mj-lt"/>
+              <a:buAutoNum type="arabicPeriod"/>
+            </a:pPr>
+            <a:r>
+              <a:rPr lang="de-DE" sz="1400" dirty="0" err="1">
+                <a:solidFill>
+                  <a:schemeClr val="tx1"/>
+                </a:solidFill>
+              </a:rPr>
+              <a:t>meet</a:t>
+            </a:r>
+            <a:r>
+              <a:rPr lang="de-DE" sz="1400" dirty="0">
+                <a:solidFill>
+                  <a:schemeClr val="tx1"/>
+                </a:solidFill>
+              </a:rPr>
+              <a:t> </a:t>
+            </a:r>
+            <a:r>
+              <a:rPr lang="de-DE" sz="1400" dirty="0" err="1">
+                <a:solidFill>
+                  <a:schemeClr val="tx1"/>
+                </a:solidFill>
+              </a:rPr>
+              <a:t>with</a:t>
+            </a:r>
+            <a:r>
+              <a:rPr lang="de-DE" sz="1400" dirty="0">
+                <a:solidFill>
+                  <a:schemeClr val="tx1"/>
+                </a:solidFill>
+              </a:rPr>
+              <a:t> Irakli </a:t>
+            </a:r>
+            <a:r>
+              <a:rPr lang="de-DE" sz="1400" dirty="0" err="1">
+                <a:solidFill>
+                  <a:schemeClr val="tx1"/>
+                </a:solidFill>
+              </a:rPr>
+              <a:t>talk</a:t>
+            </a:r>
+            <a:r>
+              <a:rPr lang="de-DE" sz="1400" dirty="0">
+                <a:solidFill>
+                  <a:schemeClr val="tx1"/>
+                </a:solidFill>
+              </a:rPr>
+              <a:t> </a:t>
+            </a:r>
+            <a:r>
+              <a:rPr lang="de-DE" sz="1400" dirty="0" err="1">
+                <a:solidFill>
+                  <a:schemeClr val="tx1"/>
+                </a:solidFill>
+              </a:rPr>
+              <a:t>about</a:t>
+            </a:r>
+            <a:r>
+              <a:rPr lang="de-DE" sz="1400" dirty="0">
+                <a:solidFill>
+                  <a:schemeClr val="tx1"/>
+                </a:solidFill>
+              </a:rPr>
+              <a:t> </a:t>
+            </a:r>
+            <a:r>
+              <a:rPr lang="de-DE" sz="1400" dirty="0" err="1">
+                <a:solidFill>
+                  <a:schemeClr val="tx1"/>
+                </a:solidFill>
+              </a:rPr>
+              <a:t>feedbacks</a:t>
+            </a:r>
+            <a:endParaRPr lang="de-DE" sz="1400" dirty="0">
+              <a:solidFill>
+                <a:schemeClr val="tx1"/>
+              </a:solidFill>
+            </a:endParaRPr>
+          </a:p>
+          <a:p>
+            <a:pPr marL="342900" indent="-342900">
+              <a:buFont typeface="+mj-lt"/>
+              <a:buAutoNum type="arabicPeriod"/>
+            </a:pPr>
+            <a:endParaRPr lang="de-DE" sz="1400" dirty="0"/>
+          </a:p>
+          <a:p>
+            <a:pPr marL="0" indent="0">
+              <a:buNone/>
+            </a:pPr>
+            <a:r>
+              <a:rPr lang="de-DE" b="1" dirty="0"/>
+              <a:t>Questions / </a:t>
+            </a:r>
+            <a:r>
+              <a:rPr lang="de-DE" b="1" dirty="0" err="1"/>
+              <a:t>Ideas</a:t>
+            </a:r>
+            <a:endParaRPr lang="de-DE" b="1" dirty="0"/>
+          </a:p>
+          <a:p>
+            <a:pPr marL="342900" indent="-342900">
+              <a:buFont typeface="+mj-lt"/>
+              <a:buAutoNum type="arabicPeriod"/>
+            </a:pPr>
+            <a:r>
+              <a:rPr lang="de-DE" sz="1400" dirty="0" err="1"/>
+              <a:t>multistate</a:t>
+            </a:r>
+            <a:r>
+              <a:rPr lang="de-DE" sz="1400" dirty="0"/>
+              <a:t> </a:t>
+            </a:r>
+            <a:r>
+              <a:rPr lang="de-DE" sz="1400" dirty="0" err="1"/>
+              <a:t>leds</a:t>
+            </a:r>
+            <a:r>
+              <a:rPr lang="de-DE" sz="1400" dirty="0"/>
+              <a:t> </a:t>
+            </a:r>
+            <a:r>
+              <a:rPr lang="de-DE" sz="1400" dirty="0" err="1"/>
+              <a:t>make</a:t>
+            </a:r>
+            <a:r>
+              <a:rPr lang="de-DE" sz="1400" dirty="0"/>
+              <a:t> </a:t>
+            </a:r>
+            <a:r>
+              <a:rPr lang="de-DE" sz="1400" dirty="0" err="1"/>
+              <a:t>error</a:t>
+            </a:r>
+            <a:r>
+              <a:rPr lang="de-DE" sz="1400" dirty="0"/>
+              <a:t>, </a:t>
+            </a:r>
+            <a:r>
+              <a:rPr lang="de-DE" sz="1400" dirty="0" err="1"/>
+              <a:t>warning</a:t>
+            </a:r>
+            <a:r>
+              <a:rPr lang="de-DE" sz="1400" dirty="0"/>
+              <a:t>, ok</a:t>
+            </a:r>
+          </a:p>
+          <a:p>
+            <a:pPr marL="342900" indent="-342900">
+              <a:buFont typeface="+mj-lt"/>
+              <a:buAutoNum type="arabicPeriod"/>
+            </a:pPr>
+            <a:r>
+              <a:rPr lang="de-DE" sz="1400" dirty="0" err="1"/>
+              <a:t>for</a:t>
+            </a:r>
+            <a:r>
+              <a:rPr lang="de-DE" sz="1400" dirty="0"/>
+              <a:t> </a:t>
+            </a:r>
+            <a:r>
+              <a:rPr lang="de-DE" sz="1400" dirty="0" err="1"/>
+              <a:t>plsci</a:t>
+            </a:r>
+            <a:r>
+              <a:rPr lang="de-DE" sz="1400" dirty="0"/>
+              <a:t> </a:t>
+            </a:r>
+            <a:r>
+              <a:rPr lang="de-DE" sz="1400" dirty="0" err="1"/>
+              <a:t>it</a:t>
+            </a:r>
+            <a:r>
+              <a:rPr lang="de-DE" sz="1400" dirty="0"/>
+              <a:t> </a:t>
+            </a:r>
+            <a:r>
+              <a:rPr lang="de-DE" sz="1400" dirty="0" err="1"/>
+              <a:t>may</a:t>
+            </a:r>
+            <a:r>
+              <a:rPr lang="de-DE" sz="1400" dirty="0"/>
+              <a:t> </a:t>
+            </a:r>
+            <a:r>
+              <a:rPr lang="de-DE" sz="1400" dirty="0" err="1"/>
+              <a:t>be</a:t>
+            </a:r>
+            <a:r>
+              <a:rPr lang="de-DE" sz="1400" dirty="0"/>
+              <a:t> </a:t>
+            </a:r>
+            <a:r>
+              <a:rPr lang="de-DE" sz="1400" dirty="0" err="1"/>
+              <a:t>used</a:t>
+            </a:r>
+            <a:r>
+              <a:rPr lang="de-DE" sz="1400" dirty="0"/>
+              <a:t> tank/</a:t>
+            </a:r>
+            <a:r>
+              <a:rPr lang="de-DE" sz="1400" dirty="0" err="1"/>
+              <a:t>progress</a:t>
+            </a:r>
+            <a:r>
+              <a:rPr lang="de-DE" sz="1400" dirty="0"/>
+              <a:t> bar </a:t>
+            </a:r>
+            <a:r>
+              <a:rPr lang="de-DE" sz="1400" dirty="0" err="1"/>
+              <a:t>for</a:t>
+            </a:r>
+            <a:r>
+              <a:rPr lang="de-DE" sz="1400" dirty="0"/>
+              <a:t> HV_I_RBV</a:t>
+            </a:r>
+          </a:p>
+          <a:p>
+            <a:pPr marL="300038" lvl="1" indent="0">
+              <a:buNone/>
+            </a:pPr>
+            <a:endParaRPr lang="de-DE" sz="1000" dirty="0"/>
+          </a:p>
+        </p:txBody>
+      </p:sp>
+    </p:spTree>
+    <p:extLst>
+      <p:ext uri="{BB962C8B-B14F-4D97-AF65-F5344CB8AC3E}">
+        <p14:creationId xmlns:p14="http://schemas.microsoft.com/office/powerpoint/2010/main" val="322367350"/>
       </p:ext>
     </p:extLst>
   </p:cSld>

</xml_diff>

<commit_message>
MUSIC updated v3 - two sections for HV
</commit_message>
<xml_diff>
--- a/CSS_examples/Documentation && Report/CSS works.pptx
+++ b/CSS_examples/Documentation && Report/CSS works.pptx
@@ -5,10 +5,10 @@
     <p:sldMasterId id="2147483648" r:id="rId1"/>
   </p:sldMasterIdLst>
   <p:notesMasterIdLst>
-    <p:notesMasterId r:id="rId23"/>
+    <p:notesMasterId r:id="rId25"/>
   </p:notesMasterIdLst>
   <p:handoutMasterIdLst>
-    <p:handoutMasterId r:id="rId24"/>
+    <p:handoutMasterId r:id="rId26"/>
   </p:handoutMasterIdLst>
   <p:sldIdLst>
     <p:sldId id="256" r:id="rId2"/>
@@ -32,6 +32,8 @@
     <p:sldId id="274" r:id="rId20"/>
     <p:sldId id="275" r:id="rId21"/>
     <p:sldId id="276" r:id="rId22"/>
+    <p:sldId id="277" r:id="rId23"/>
+    <p:sldId id="278" r:id="rId24"/>
   </p:sldIdLst>
   <p:sldSz cx="9144000" cy="5143500" type="screen16x9"/>
   <p:notesSz cx="7104063" cy="10234613"/>
@@ -231,7 +233,7 @@
           <a:p>
             <a:fld id="{0B851660-0934-124D-A4B3-496C7F320307}" type="datetimeFigureOut">
               <a:rPr lang="de-DE" smtClean="0"/>
-              <a:t>25.08.2026</a:t>
+              <a:t>27.08.2026</a:t>
             </a:fld>
             <a:endParaRPr lang="de-DE"/>
           </a:p>
@@ -397,7 +399,7 @@
           <a:p>
             <a:fld id="{98C828EF-C252-394A-93BF-1C478CFA0896}" type="datetimeFigureOut">
               <a:rPr lang="de-DE" smtClean="0"/>
-              <a:t>25.08.2026</a:t>
+              <a:t>27.08.2026</a:t>
             </a:fld>
             <a:endParaRPr lang="de-DE"/>
           </a:p>
@@ -9453,7 +9455,7 @@
               <a:buAutoNum type="arabicPeriod"/>
             </a:pPr>
             <a:r>
-              <a:rPr lang="de-DE" sz="1400" dirty="0" err="1">
+              <a:rPr lang="de-DE" sz="1400" strike="sngStrike" dirty="0" err="1">
                 <a:solidFill>
                   <a:schemeClr val="tx1"/>
                 </a:solidFill>
@@ -9461,15 +9463,15 @@
               <a:t>make</a:t>
             </a:r>
             <a:r>
-              <a:rPr lang="de-DE" sz="1400" dirty="0">
-                <a:solidFill>
-                  <a:schemeClr val="tx1"/>
-                </a:solidFill>
-              </a:rPr>
-              <a:t> </a:t>
-            </a:r>
-            <a:r>
-              <a:rPr lang="de-DE" sz="1400" dirty="0" err="1">
+              <a:rPr lang="de-DE" sz="1400" strike="sngStrike" dirty="0">
+                <a:solidFill>
+                  <a:schemeClr val="tx1"/>
+                </a:solidFill>
+              </a:rPr>
+              <a:t> </a:t>
+            </a:r>
+            <a:r>
+              <a:rPr lang="de-DE" sz="1400" strike="sngStrike" dirty="0" err="1">
                 <a:solidFill>
                   <a:schemeClr val="tx1"/>
                 </a:solidFill>
@@ -9477,15 +9479,15 @@
               <a:t>settings</a:t>
             </a:r>
             <a:r>
-              <a:rPr lang="de-DE" sz="1400" dirty="0">
-                <a:solidFill>
-                  <a:schemeClr val="tx1"/>
-                </a:solidFill>
-              </a:rPr>
-              <a:t> </a:t>
-            </a:r>
-            <a:r>
-              <a:rPr lang="de-DE" sz="1400" dirty="0" err="1">
+              <a:rPr lang="de-DE" sz="1400" strike="sngStrike" dirty="0">
+                <a:solidFill>
+                  <a:schemeClr val="tx1"/>
+                </a:solidFill>
+              </a:rPr>
+              <a:t> </a:t>
+            </a:r>
+            <a:r>
+              <a:rPr lang="de-DE" sz="1400" strike="sngStrike" dirty="0" err="1">
                 <a:solidFill>
                   <a:schemeClr val="tx1"/>
                 </a:solidFill>
@@ -9493,15 +9495,15 @@
               <a:t>file</a:t>
             </a:r>
             <a:r>
-              <a:rPr lang="de-DE" sz="1400" dirty="0">
-                <a:solidFill>
-                  <a:schemeClr val="tx1"/>
-                </a:solidFill>
-              </a:rPr>
-              <a:t> </a:t>
-            </a:r>
-            <a:r>
-              <a:rPr lang="de-DE" sz="1400" dirty="0" err="1">
+              <a:rPr lang="de-DE" sz="1400" strike="sngStrike" dirty="0">
+                <a:solidFill>
+                  <a:schemeClr val="tx1"/>
+                </a:solidFill>
+              </a:rPr>
+              <a:t> </a:t>
+            </a:r>
+            <a:r>
+              <a:rPr lang="de-DE" sz="1400" strike="sngStrike" dirty="0" err="1">
                 <a:solidFill>
                   <a:schemeClr val="tx1"/>
                 </a:solidFill>
@@ -9509,7 +9511,7 @@
               <a:t>that</a:t>
             </a:r>
             <a:r>
-              <a:rPr lang="de-DE" sz="1400" dirty="0">
+              <a:rPr lang="de-DE" sz="1400" strike="sngStrike" dirty="0">
                 <a:solidFill>
                   <a:schemeClr val="tx1"/>
                 </a:solidFill>
@@ -9517,7 +9519,7 @@
               <a:t> will </a:t>
             </a:r>
             <a:r>
-              <a:rPr lang="de-DE" sz="1400" dirty="0" err="1">
+              <a:rPr lang="de-DE" sz="1400" strike="sngStrike" dirty="0" err="1">
                 <a:solidFill>
                   <a:schemeClr val="tx1"/>
                 </a:solidFill>
@@ -9525,15 +9527,15 @@
               <a:t>be</a:t>
             </a:r>
             <a:r>
-              <a:rPr lang="de-DE" sz="1400" dirty="0">
-                <a:solidFill>
-                  <a:schemeClr val="tx1"/>
-                </a:solidFill>
-              </a:rPr>
-              <a:t> </a:t>
-            </a:r>
-            <a:r>
-              <a:rPr lang="de-DE" sz="1400" dirty="0" err="1">
+              <a:rPr lang="de-DE" sz="1400" strike="sngStrike" dirty="0">
+                <a:solidFill>
+                  <a:schemeClr val="tx1"/>
+                </a:solidFill>
+              </a:rPr>
+              <a:t> </a:t>
+            </a:r>
+            <a:r>
+              <a:rPr lang="de-DE" sz="1400" strike="sngStrike" dirty="0" err="1">
                 <a:solidFill>
                   <a:schemeClr val="tx1"/>
                 </a:solidFill>
@@ -9541,15 +9543,15 @@
               <a:t>automatized</a:t>
             </a:r>
             <a:r>
-              <a:rPr lang="de-DE" sz="1400" dirty="0">
-                <a:solidFill>
-                  <a:schemeClr val="tx1"/>
-                </a:solidFill>
-              </a:rPr>
-              <a:t> </a:t>
-            </a:r>
-            <a:r>
-              <a:rPr lang="de-DE" sz="1400" dirty="0" err="1">
+              <a:rPr lang="de-DE" sz="1400" strike="sngStrike" dirty="0">
+                <a:solidFill>
+                  <a:schemeClr val="tx1"/>
+                </a:solidFill>
+              </a:rPr>
+              <a:t> </a:t>
+            </a:r>
+            <a:r>
+              <a:rPr lang="de-DE" sz="1400" strike="sngStrike" dirty="0" err="1">
                 <a:solidFill>
                   <a:schemeClr val="tx1"/>
                 </a:solidFill>
@@ -9557,15 +9559,15 @@
               <a:t>later</a:t>
             </a:r>
             <a:r>
-              <a:rPr lang="de-DE" sz="1400" dirty="0">
-                <a:solidFill>
-                  <a:schemeClr val="tx1"/>
-                </a:solidFill>
-              </a:rPr>
-              <a:t> </a:t>
-            </a:r>
-            <a:r>
-              <a:rPr lang="de-DE" sz="1400" dirty="0" err="1">
+              <a:rPr lang="de-DE" sz="1400" strike="sngStrike" dirty="0">
+                <a:solidFill>
+                  <a:schemeClr val="tx1"/>
+                </a:solidFill>
+              </a:rPr>
+              <a:t> </a:t>
+            </a:r>
+            <a:r>
+              <a:rPr lang="de-DE" sz="1400" strike="sngStrike" dirty="0" err="1">
                 <a:solidFill>
                   <a:schemeClr val="tx1"/>
                 </a:solidFill>
@@ -9573,15 +9575,15 @@
               <a:t>when</a:t>
             </a:r>
             <a:r>
-              <a:rPr lang="de-DE" sz="1400" dirty="0">
-                <a:solidFill>
-                  <a:schemeClr val="tx1"/>
-                </a:solidFill>
-              </a:rPr>
-              <a:t> </a:t>
-            </a:r>
-            <a:r>
-              <a:rPr lang="de-DE" sz="1400" dirty="0" err="1">
+              <a:rPr lang="de-DE" sz="1400" strike="sngStrike" dirty="0">
+                <a:solidFill>
+                  <a:schemeClr val="tx1"/>
+                </a:solidFill>
+              </a:rPr>
+              <a:t> </a:t>
+            </a:r>
+            <a:r>
+              <a:rPr lang="de-DE" sz="1400" strike="sngStrike" dirty="0" err="1">
                 <a:solidFill>
                   <a:schemeClr val="tx1"/>
                 </a:solidFill>
@@ -9589,15 +9591,15 @@
               <a:t>we</a:t>
             </a:r>
             <a:r>
-              <a:rPr lang="de-DE" sz="1400" dirty="0">
-                <a:solidFill>
-                  <a:schemeClr val="tx1"/>
-                </a:solidFill>
-              </a:rPr>
-              <a:t> </a:t>
-            </a:r>
-            <a:r>
-              <a:rPr lang="de-DE" sz="1400" dirty="0" err="1">
+              <a:rPr lang="de-DE" sz="1400" strike="sngStrike" dirty="0">
+                <a:solidFill>
+                  <a:schemeClr val="tx1"/>
+                </a:solidFill>
+              </a:rPr>
+              <a:t> </a:t>
+            </a:r>
+            <a:r>
+              <a:rPr lang="de-DE" sz="1400" strike="sngStrike" dirty="0" err="1">
                 <a:solidFill>
                   <a:schemeClr val="tx1"/>
                 </a:solidFill>
@@ -9605,7 +9607,7 @@
               <a:t>have</a:t>
             </a:r>
             <a:r>
-              <a:rPr lang="de-DE" sz="1400" dirty="0">
+              <a:rPr lang="de-DE" sz="1400" strike="sngStrike" dirty="0">
                 <a:solidFill>
                   <a:schemeClr val="tx1"/>
                 </a:solidFill>
@@ -9613,7 +9615,7 @@
               <a:t> different </a:t>
             </a:r>
             <a:r>
-              <a:rPr lang="de-DE" sz="1400" dirty="0" err="1">
+              <a:rPr lang="de-DE" sz="1400" strike="sngStrike" dirty="0" err="1">
                 <a:solidFill>
                   <a:schemeClr val="tx1"/>
                 </a:solidFill>
@@ -9621,22 +9623,22 @@
               <a:t>layout</a:t>
             </a:r>
             <a:r>
-              <a:rPr lang="de-DE" sz="1400" dirty="0">
-                <a:solidFill>
-                  <a:schemeClr val="tx1"/>
-                </a:solidFill>
-              </a:rPr>
-              <a:t> </a:t>
-            </a:r>
-            <a:r>
-              <a:rPr lang="de-DE" sz="1400" dirty="0" err="1">
+              <a:rPr lang="de-DE" sz="1400" strike="sngStrike" dirty="0">
+                <a:solidFill>
+                  <a:schemeClr val="tx1"/>
+                </a:solidFill>
+              </a:rPr>
+              <a:t> </a:t>
+            </a:r>
+            <a:r>
+              <a:rPr lang="de-DE" sz="1400" strike="sngStrike" dirty="0" err="1">
                 <a:solidFill>
                   <a:schemeClr val="tx1"/>
                 </a:solidFill>
               </a:rPr>
               <a:t>ideas</a:t>
             </a:r>
-            <a:endParaRPr lang="de-DE" sz="1400" dirty="0">
+            <a:endParaRPr lang="de-DE" sz="1400" strike="sngStrike" dirty="0">
               <a:solidFill>
                 <a:schemeClr val="tx1"/>
               </a:solidFill>
@@ -10075,6 +10077,1459 @@
     <p:extLst>
       <p:ext uri="{BB962C8B-B14F-4D97-AF65-F5344CB8AC3E}">
         <p14:creationId xmlns:p14="http://schemas.microsoft.com/office/powerpoint/2010/main" val="322367350"/>
+      </p:ext>
+    </p:extLst>
+  </p:cSld>
+  <p:clrMapOvr>
+    <a:masterClrMapping/>
+  </p:clrMapOvr>
+</p:sld>
+</file>
+
+<file path=ppt/slides/slide22.xml><?xml version="1.0" encoding="utf-8"?>
+<p:sld xmlns:a="http://schemas.openxmlformats.org/drawingml/2006/main" xmlns:r="http://schemas.openxmlformats.org/officeDocument/2006/relationships" xmlns:p="http://schemas.openxmlformats.org/presentationml/2006/main">
+  <p:cSld>
+    <p:spTree>
+      <p:nvGrpSpPr>
+        <p:cNvPr id="1" name=""/>
+        <p:cNvGrpSpPr/>
+        <p:nvPr/>
+      </p:nvGrpSpPr>
+      <p:grpSpPr>
+        <a:xfrm>
+          <a:off x="0" y="0"/>
+          <a:ext cx="0" cy="0"/>
+          <a:chOff x="0" y="0"/>
+          <a:chExt cx="0" cy="0"/>
+        </a:xfrm>
+      </p:grpSpPr>
+      <p:sp>
+        <p:nvSpPr>
+          <p:cNvPr id="2" name="Title 1">
+            <a:extLst>
+              <a:ext uri="{FF2B5EF4-FFF2-40B4-BE49-F238E27FC236}">
+                <a16:creationId xmlns:a16="http://schemas.microsoft.com/office/drawing/2014/main" id="{2B3507EB-96BE-4214-997D-D5198E71A376}"/>
+              </a:ext>
+            </a:extLst>
+          </p:cNvPr>
+          <p:cNvSpPr>
+            <a:spLocks noGrp="1"/>
+          </p:cNvSpPr>
+          <p:nvPr>
+            <p:ph type="title"/>
+          </p:nvPr>
+        </p:nvSpPr>
+        <p:spPr/>
+        <p:txBody>
+          <a:bodyPr/>
+          <a:lstStyle/>
+          <a:p>
+            <a:r>
+              <a:rPr lang="de-DE" dirty="0" err="1"/>
+              <a:t>Example</a:t>
+            </a:r>
+            <a:r>
+              <a:rPr lang="de-DE" dirty="0"/>
+              <a:t> – Day 11-13</a:t>
+            </a:r>
+          </a:p>
+        </p:txBody>
+      </p:sp>
+      <p:pic>
+        <p:nvPicPr>
+          <p:cNvPr id="6" name="Picture 5">
+            <a:extLst>
+              <a:ext uri="{FF2B5EF4-FFF2-40B4-BE49-F238E27FC236}">
+                <a16:creationId xmlns:a16="http://schemas.microsoft.com/office/drawing/2014/main" id="{1051348D-92A5-4E52-80EB-2A0105FA5A9F}"/>
+              </a:ext>
+            </a:extLst>
+          </p:cNvPr>
+          <p:cNvPicPr>
+            <a:picLocks noChangeAspect="1"/>
+          </p:cNvPicPr>
+          <p:nvPr/>
+        </p:nvPicPr>
+        <p:blipFill>
+          <a:blip r:embed="rId2"/>
+          <a:stretch>
+            <a:fillRect/>
+          </a:stretch>
+        </p:blipFill>
+        <p:spPr>
+          <a:xfrm>
+            <a:off x="0" y="2167004"/>
+            <a:ext cx="3068816" cy="809491"/>
+          </a:xfrm>
+          <a:prstGeom prst="rect">
+            <a:avLst/>
+          </a:prstGeom>
+        </p:spPr>
+      </p:pic>
+      <p:pic>
+        <p:nvPicPr>
+          <p:cNvPr id="8" name="Picture 7">
+            <a:extLst>
+              <a:ext uri="{FF2B5EF4-FFF2-40B4-BE49-F238E27FC236}">
+                <a16:creationId xmlns:a16="http://schemas.microsoft.com/office/drawing/2014/main" id="{0EE4EBFF-E317-4A08-AA00-BD2C77DDFAD6}"/>
+              </a:ext>
+            </a:extLst>
+          </p:cNvPr>
+          <p:cNvPicPr>
+            <a:picLocks noChangeAspect="1"/>
+          </p:cNvPicPr>
+          <p:nvPr/>
+        </p:nvPicPr>
+        <p:blipFill>
+          <a:blip r:embed="rId3"/>
+          <a:stretch>
+            <a:fillRect/>
+          </a:stretch>
+        </p:blipFill>
+        <p:spPr>
+          <a:xfrm>
+            <a:off x="3100883" y="934648"/>
+            <a:ext cx="6011050" cy="3978455"/>
+          </a:xfrm>
+          <a:prstGeom prst="rect">
+            <a:avLst/>
+          </a:prstGeom>
+        </p:spPr>
+      </p:pic>
+    </p:spTree>
+    <p:extLst>
+      <p:ext uri="{BB962C8B-B14F-4D97-AF65-F5344CB8AC3E}">
+        <p14:creationId xmlns:p14="http://schemas.microsoft.com/office/powerpoint/2010/main" val="1034395464"/>
+      </p:ext>
+    </p:extLst>
+  </p:cSld>
+  <p:clrMapOvr>
+    <a:masterClrMapping/>
+  </p:clrMapOvr>
+</p:sld>
+</file>
+
+<file path=ppt/slides/slide23.xml><?xml version="1.0" encoding="utf-8"?>
+<p:sld xmlns:a="http://schemas.openxmlformats.org/drawingml/2006/main" xmlns:r="http://schemas.openxmlformats.org/officeDocument/2006/relationships" xmlns:p="http://schemas.openxmlformats.org/presentationml/2006/main">
+  <p:cSld>
+    <p:spTree>
+      <p:nvGrpSpPr>
+        <p:cNvPr id="1" name=""/>
+        <p:cNvGrpSpPr/>
+        <p:nvPr/>
+      </p:nvGrpSpPr>
+      <p:grpSpPr>
+        <a:xfrm>
+          <a:off x="0" y="0"/>
+          <a:ext cx="0" cy="0"/>
+          <a:chOff x="0" y="0"/>
+          <a:chExt cx="0" cy="0"/>
+        </a:xfrm>
+      </p:grpSpPr>
+      <p:sp>
+        <p:nvSpPr>
+          <p:cNvPr id="2" name="Title 1">
+            <a:extLst>
+              <a:ext uri="{FF2B5EF4-FFF2-40B4-BE49-F238E27FC236}">
+                <a16:creationId xmlns:a16="http://schemas.microsoft.com/office/drawing/2014/main" id="{C4F020AE-CD6F-4C87-8B44-2242F3095430}"/>
+              </a:ext>
+            </a:extLst>
+          </p:cNvPr>
+          <p:cNvSpPr>
+            <a:spLocks noGrp="1"/>
+          </p:cNvSpPr>
+          <p:nvPr>
+            <p:ph type="title"/>
+          </p:nvPr>
+        </p:nvSpPr>
+        <p:spPr/>
+        <p:txBody>
+          <a:bodyPr/>
+          <a:lstStyle/>
+          <a:p>
+            <a:r>
+              <a:rPr lang="de-DE" dirty="0"/>
+              <a:t>Report 26.08.27</a:t>
+            </a:r>
+          </a:p>
+        </p:txBody>
+      </p:sp>
+      <p:sp>
+        <p:nvSpPr>
+          <p:cNvPr id="4" name="Content Placeholder 2">
+            <a:extLst>
+              <a:ext uri="{FF2B5EF4-FFF2-40B4-BE49-F238E27FC236}">
+                <a16:creationId xmlns:a16="http://schemas.microsoft.com/office/drawing/2014/main" id="{FA77772D-0DBC-49CF-A5F5-2F8530CE8539}"/>
+              </a:ext>
+            </a:extLst>
+          </p:cNvPr>
+          <p:cNvSpPr>
+            <a:spLocks noGrp="1"/>
+          </p:cNvSpPr>
+          <p:nvPr>
+            <p:ph idx="1"/>
+          </p:nvPr>
+        </p:nvSpPr>
+        <p:spPr>
+          <a:xfrm>
+            <a:off x="317500" y="1087438"/>
+            <a:ext cx="8420100" cy="3678237"/>
+          </a:xfrm>
+        </p:spPr>
+        <p:txBody>
+          <a:bodyPr/>
+          <a:lstStyle/>
+          <a:p>
+            <a:pPr marL="0" indent="0">
+              <a:buNone/>
+            </a:pPr>
+            <a:r>
+              <a:rPr lang="de-DE" b="1" dirty="0" err="1"/>
+              <a:t>Suggested</a:t>
+            </a:r>
+            <a:endParaRPr lang="de-DE" b="1" dirty="0"/>
+          </a:p>
+          <a:p>
+            <a:pPr marL="342900" indent="-342900">
+              <a:buFont typeface="+mj-lt"/>
+              <a:buAutoNum type="arabicPeriod"/>
+            </a:pPr>
+            <a:r>
+              <a:rPr lang="de-DE" sz="1400" dirty="0" err="1">
+                <a:solidFill>
+                  <a:srgbClr val="FF0000"/>
+                </a:solidFill>
+              </a:rPr>
+              <a:t>to</a:t>
+            </a:r>
+            <a:r>
+              <a:rPr lang="de-DE" sz="1400" dirty="0">
+                <a:solidFill>
+                  <a:srgbClr val="FF0000"/>
+                </a:solidFill>
+              </a:rPr>
+              <a:t> </a:t>
+            </a:r>
+            <a:r>
+              <a:rPr lang="de-DE" sz="1400" dirty="0" err="1">
+                <a:solidFill>
+                  <a:srgbClr val="FF0000"/>
+                </a:solidFill>
+              </a:rPr>
+              <a:t>think</a:t>
+            </a:r>
+            <a:r>
+              <a:rPr lang="de-DE" sz="1400" dirty="0">
+                <a:solidFill>
+                  <a:srgbClr val="FF0000"/>
+                </a:solidFill>
+              </a:rPr>
+              <a:t> </a:t>
+            </a:r>
+            <a:r>
+              <a:rPr lang="de-DE" sz="1400" dirty="0" err="1">
+                <a:solidFill>
+                  <a:srgbClr val="FF0000"/>
+                </a:solidFill>
+              </a:rPr>
+              <a:t>click</a:t>
+            </a:r>
+            <a:r>
+              <a:rPr lang="de-DE" sz="1400" dirty="0">
+                <a:solidFill>
+                  <a:srgbClr val="FF0000"/>
+                </a:solidFill>
+              </a:rPr>
+              <a:t> a </a:t>
+            </a:r>
+            <a:r>
+              <a:rPr lang="de-DE" sz="1400" dirty="0" err="1">
+                <a:solidFill>
+                  <a:srgbClr val="FF0000"/>
+                </a:solidFill>
+              </a:rPr>
+              <a:t>button</a:t>
+            </a:r>
+            <a:r>
+              <a:rPr lang="de-DE" sz="1400" dirty="0">
+                <a:solidFill>
+                  <a:srgbClr val="FF0000"/>
+                </a:solidFill>
+              </a:rPr>
+              <a:t> </a:t>
+            </a:r>
+            <a:r>
+              <a:rPr lang="de-DE" sz="1400" dirty="0" err="1">
+                <a:solidFill>
+                  <a:srgbClr val="FF0000"/>
+                </a:solidFill>
+              </a:rPr>
+              <a:t>to</a:t>
+            </a:r>
+            <a:r>
+              <a:rPr lang="de-DE" sz="1400" dirty="0">
+                <a:solidFill>
+                  <a:srgbClr val="FF0000"/>
+                </a:solidFill>
+              </a:rPr>
+              <a:t> open a </a:t>
+            </a:r>
+            <a:r>
+              <a:rPr lang="de-DE" sz="1400" dirty="0" err="1">
+                <a:solidFill>
+                  <a:srgbClr val="FF0000"/>
+                </a:solidFill>
+              </a:rPr>
+              <a:t>new</a:t>
+            </a:r>
+            <a:r>
+              <a:rPr lang="de-DE" sz="1400" dirty="0">
+                <a:solidFill>
+                  <a:srgbClr val="FF0000"/>
+                </a:solidFill>
+              </a:rPr>
+              <a:t> </a:t>
+            </a:r>
+            <a:r>
+              <a:rPr lang="de-DE" sz="1400" dirty="0" err="1">
+                <a:solidFill>
+                  <a:srgbClr val="FF0000"/>
+                </a:solidFill>
+              </a:rPr>
+              <a:t>tab</a:t>
+            </a:r>
+            <a:endParaRPr lang="de-DE" sz="1400" dirty="0">
+              <a:solidFill>
+                <a:srgbClr val="FF0000"/>
+              </a:solidFill>
+            </a:endParaRPr>
+          </a:p>
+          <a:p>
+            <a:pPr marL="342900" indent="-342900">
+              <a:buFont typeface="+mj-lt"/>
+              <a:buAutoNum type="arabicPeriod"/>
+            </a:pPr>
+            <a:r>
+              <a:rPr lang="de-DE" sz="1400" strike="sngStrike" dirty="0" err="1">
+                <a:solidFill>
+                  <a:schemeClr val="tx1"/>
+                </a:solidFill>
+              </a:rPr>
+              <a:t>there</a:t>
+            </a:r>
+            <a:r>
+              <a:rPr lang="de-DE" sz="1400" strike="sngStrike" dirty="0">
+                <a:solidFill>
+                  <a:schemeClr val="tx1"/>
+                </a:solidFill>
+              </a:rPr>
+              <a:t> will </a:t>
+            </a:r>
+            <a:r>
+              <a:rPr lang="de-DE" sz="1400" strike="sngStrike" dirty="0" err="1">
+                <a:solidFill>
+                  <a:schemeClr val="tx1"/>
+                </a:solidFill>
+              </a:rPr>
+              <a:t>come</a:t>
+            </a:r>
+            <a:r>
+              <a:rPr lang="de-DE" sz="1400" strike="sngStrike" dirty="0">
+                <a:solidFill>
+                  <a:schemeClr val="tx1"/>
+                </a:solidFill>
+              </a:rPr>
+              <a:t> </a:t>
+            </a:r>
+            <a:r>
+              <a:rPr lang="de-DE" sz="1400" strike="sngStrike" dirty="0" err="1">
+                <a:solidFill>
+                  <a:schemeClr val="tx1"/>
+                </a:solidFill>
+              </a:rPr>
+              <a:t>one</a:t>
+            </a:r>
+            <a:r>
+              <a:rPr lang="de-DE" sz="1400" strike="sngStrike" dirty="0">
+                <a:solidFill>
+                  <a:schemeClr val="tx1"/>
+                </a:solidFill>
+              </a:rPr>
+              <a:t> </a:t>
+            </a:r>
+            <a:r>
+              <a:rPr lang="de-DE" sz="1400" strike="sngStrike" dirty="0" err="1">
+                <a:solidFill>
+                  <a:schemeClr val="tx1"/>
+                </a:solidFill>
+              </a:rPr>
+              <a:t>more</a:t>
+            </a:r>
+            <a:r>
+              <a:rPr lang="de-DE" sz="1400" strike="sngStrike" dirty="0">
+                <a:solidFill>
+                  <a:schemeClr val="tx1"/>
+                </a:solidFill>
+              </a:rPr>
+              <a:t> HV </a:t>
+            </a:r>
+            <a:r>
+              <a:rPr lang="de-DE" sz="1400" strike="sngStrike" dirty="0" err="1">
+                <a:solidFill>
+                  <a:schemeClr val="tx1"/>
+                </a:solidFill>
+              </a:rPr>
+              <a:t>for</a:t>
+            </a:r>
+            <a:r>
+              <a:rPr lang="de-DE" sz="1400" strike="sngStrike" dirty="0">
+                <a:solidFill>
+                  <a:schemeClr val="tx1"/>
+                </a:solidFill>
+              </a:rPr>
+              <a:t> </a:t>
+            </a:r>
+            <a:r>
+              <a:rPr lang="de-DE" sz="1400" strike="sngStrike" dirty="0" err="1">
+                <a:solidFill>
+                  <a:schemeClr val="tx1"/>
+                </a:solidFill>
+              </a:rPr>
+              <a:t>pos</a:t>
+            </a:r>
+            <a:r>
+              <a:rPr lang="de-DE" sz="1400" strike="sngStrike" dirty="0">
+                <a:solidFill>
+                  <a:schemeClr val="tx1"/>
+                </a:solidFill>
+              </a:rPr>
+              <a:t> </a:t>
+            </a:r>
+            <a:r>
+              <a:rPr lang="de-DE" sz="1400" strike="sngStrike" dirty="0" err="1">
+                <a:solidFill>
+                  <a:schemeClr val="tx1"/>
+                </a:solidFill>
+              </a:rPr>
+              <a:t>values</a:t>
+            </a:r>
+            <a:r>
+              <a:rPr lang="de-DE" sz="1400" strike="sngStrike" dirty="0">
+                <a:solidFill>
+                  <a:schemeClr val="tx1"/>
+                </a:solidFill>
+              </a:rPr>
+              <a:t> </a:t>
+            </a:r>
+            <a:r>
+              <a:rPr lang="de-DE" sz="1400" dirty="0">
+                <a:solidFill>
+                  <a:schemeClr val="tx1"/>
+                </a:solidFill>
+              </a:rPr>
+              <a:t>(I </a:t>
+            </a:r>
+            <a:r>
+              <a:rPr lang="de-DE" sz="1400" dirty="0" err="1">
+                <a:solidFill>
+                  <a:schemeClr val="tx1"/>
+                </a:solidFill>
+              </a:rPr>
+              <a:t>put</a:t>
+            </a:r>
+            <a:r>
+              <a:rPr lang="de-DE" sz="1400" dirty="0">
+                <a:solidFill>
+                  <a:schemeClr val="tx1"/>
+                </a:solidFill>
+              </a:rPr>
+              <a:t> </a:t>
+            </a:r>
+            <a:r>
+              <a:rPr lang="de-DE" sz="1400" dirty="0" err="1">
+                <a:solidFill>
+                  <a:schemeClr val="tx1"/>
+                </a:solidFill>
+              </a:rPr>
+              <a:t>the</a:t>
+            </a:r>
+            <a:r>
+              <a:rPr lang="de-DE" sz="1400" dirty="0">
+                <a:solidFill>
+                  <a:schemeClr val="tx1"/>
+                </a:solidFill>
+              </a:rPr>
+              <a:t> </a:t>
+            </a:r>
+            <a:r>
+              <a:rPr lang="de-DE" sz="1400" dirty="0" err="1">
+                <a:solidFill>
+                  <a:schemeClr val="tx1"/>
+                </a:solidFill>
+              </a:rPr>
+              <a:t>new</a:t>
+            </a:r>
+            <a:r>
+              <a:rPr lang="de-DE" sz="1400" dirty="0">
+                <a:solidFill>
+                  <a:schemeClr val="tx1"/>
+                </a:solidFill>
+              </a:rPr>
+              <a:t> </a:t>
+            </a:r>
+            <a:r>
+              <a:rPr lang="de-DE" sz="1400" dirty="0" err="1">
+                <a:solidFill>
+                  <a:schemeClr val="tx1"/>
+                </a:solidFill>
+              </a:rPr>
+              <a:t>section</a:t>
+            </a:r>
+            <a:r>
+              <a:rPr lang="de-DE" sz="1400" dirty="0">
+                <a:solidFill>
+                  <a:schemeClr val="tx1"/>
+                </a:solidFill>
+              </a:rPr>
+              <a:t> </a:t>
+            </a:r>
+            <a:r>
+              <a:rPr lang="de-DE" sz="1400" dirty="0" err="1">
+                <a:solidFill>
+                  <a:schemeClr val="tx1"/>
+                </a:solidFill>
+              </a:rPr>
+              <a:t>for</a:t>
+            </a:r>
+            <a:r>
+              <a:rPr lang="de-DE" sz="1400" dirty="0">
+                <a:solidFill>
+                  <a:schemeClr val="tx1"/>
+                </a:solidFill>
+              </a:rPr>
+              <a:t> 2nd power </a:t>
+            </a:r>
+            <a:r>
+              <a:rPr lang="de-DE" sz="1400" dirty="0" err="1">
+                <a:solidFill>
+                  <a:schemeClr val="tx1"/>
+                </a:solidFill>
+              </a:rPr>
+              <a:t>supply</a:t>
+            </a:r>
+            <a:r>
+              <a:rPr lang="de-DE" sz="1400" dirty="0">
+                <a:solidFill>
+                  <a:schemeClr val="tx1"/>
+                </a:solidFill>
+              </a:rPr>
+              <a:t> </a:t>
+            </a:r>
+            <a:r>
+              <a:rPr lang="de-DE" sz="1400" dirty="0" err="1">
+                <a:solidFill>
+                  <a:schemeClr val="tx1"/>
+                </a:solidFill>
+              </a:rPr>
+              <a:t>of</a:t>
+            </a:r>
+            <a:r>
+              <a:rPr lang="de-DE" sz="1400" dirty="0">
+                <a:solidFill>
+                  <a:schemeClr val="tx1"/>
+                </a:solidFill>
+              </a:rPr>
+              <a:t> MUSIC but </a:t>
+            </a:r>
+            <a:r>
+              <a:rPr lang="de-DE" sz="1400" dirty="0" err="1">
+                <a:solidFill>
+                  <a:schemeClr val="tx1"/>
+                </a:solidFill>
+              </a:rPr>
+              <a:t>there</a:t>
+            </a:r>
+            <a:r>
+              <a:rPr lang="de-DE" sz="1400" dirty="0">
+                <a:solidFill>
+                  <a:schemeClr val="tx1"/>
+                </a:solidFill>
+              </a:rPr>
+              <a:t> </a:t>
+            </a:r>
+            <a:r>
+              <a:rPr lang="de-DE" sz="1400" dirty="0" err="1">
+                <a:solidFill>
+                  <a:schemeClr val="tx1"/>
+                </a:solidFill>
+              </a:rPr>
+              <a:t>is</a:t>
+            </a:r>
+            <a:r>
+              <a:rPr lang="de-DE" sz="1400" dirty="0">
+                <a:solidFill>
+                  <a:schemeClr val="tx1"/>
+                </a:solidFill>
+              </a:rPr>
+              <a:t> </a:t>
+            </a:r>
+            <a:r>
+              <a:rPr lang="de-DE" sz="1400" dirty="0" err="1">
+                <a:solidFill>
+                  <a:schemeClr val="tx1"/>
+                </a:solidFill>
+              </a:rPr>
+              <a:t>no</a:t>
+            </a:r>
+            <a:r>
+              <a:rPr lang="de-DE" sz="1400" dirty="0">
+                <a:solidFill>
+                  <a:schemeClr val="tx1"/>
+                </a:solidFill>
+              </a:rPr>
+              <a:t> PV in EPICS </a:t>
+            </a:r>
+            <a:r>
+              <a:rPr lang="de-DE" sz="1400" dirty="0" err="1">
+                <a:solidFill>
+                  <a:schemeClr val="tx1"/>
+                </a:solidFill>
+              </a:rPr>
+              <a:t>for</a:t>
+            </a:r>
+            <a:r>
+              <a:rPr lang="de-DE" sz="1400" dirty="0">
+                <a:solidFill>
+                  <a:schemeClr val="tx1"/>
+                </a:solidFill>
+              </a:rPr>
+              <a:t> </a:t>
+            </a:r>
+            <a:r>
+              <a:rPr lang="de-DE" sz="1400" dirty="0" err="1">
+                <a:solidFill>
+                  <a:schemeClr val="tx1"/>
+                </a:solidFill>
+              </a:rPr>
+              <a:t>now</a:t>
+            </a:r>
+            <a:r>
+              <a:rPr lang="de-DE" sz="1400">
+                <a:solidFill>
+                  <a:schemeClr val="tx1"/>
+                </a:solidFill>
+              </a:rPr>
+              <a:t>)</a:t>
+            </a:r>
+            <a:endParaRPr lang="de-DE" sz="1400" strike="sngStrike" dirty="0">
+              <a:solidFill>
+                <a:schemeClr val="tx1"/>
+              </a:solidFill>
+            </a:endParaRPr>
+          </a:p>
+          <a:p>
+            <a:pPr marL="342900" indent="-342900">
+              <a:buFont typeface="+mj-lt"/>
+              <a:buAutoNum type="arabicPeriod"/>
+            </a:pPr>
+            <a:r>
+              <a:rPr lang="de-DE" sz="1400" strike="sngStrike" dirty="0" err="1">
+                <a:solidFill>
+                  <a:schemeClr val="tx1"/>
+                </a:solidFill>
+              </a:rPr>
+              <a:t>make</a:t>
+            </a:r>
+            <a:r>
+              <a:rPr lang="de-DE" sz="1400" strike="sngStrike" dirty="0">
+                <a:solidFill>
+                  <a:schemeClr val="tx1"/>
+                </a:solidFill>
+              </a:rPr>
+              <a:t> </a:t>
+            </a:r>
+            <a:r>
+              <a:rPr lang="de-DE" sz="1400" strike="sngStrike" dirty="0" err="1">
+                <a:solidFill>
+                  <a:schemeClr val="tx1"/>
+                </a:solidFill>
+              </a:rPr>
+              <a:t>settings</a:t>
+            </a:r>
+            <a:r>
+              <a:rPr lang="de-DE" sz="1400" strike="sngStrike" dirty="0">
+                <a:solidFill>
+                  <a:schemeClr val="tx1"/>
+                </a:solidFill>
+              </a:rPr>
+              <a:t> </a:t>
+            </a:r>
+            <a:r>
+              <a:rPr lang="de-DE" sz="1400" strike="sngStrike" dirty="0" err="1">
+                <a:solidFill>
+                  <a:schemeClr val="tx1"/>
+                </a:solidFill>
+              </a:rPr>
+              <a:t>file</a:t>
+            </a:r>
+            <a:r>
+              <a:rPr lang="de-DE" sz="1400" strike="sngStrike" dirty="0">
+                <a:solidFill>
+                  <a:schemeClr val="tx1"/>
+                </a:solidFill>
+              </a:rPr>
+              <a:t> </a:t>
+            </a:r>
+            <a:r>
+              <a:rPr lang="de-DE" sz="1400" strike="sngStrike" dirty="0" err="1">
+                <a:solidFill>
+                  <a:schemeClr val="tx1"/>
+                </a:solidFill>
+              </a:rPr>
+              <a:t>that</a:t>
+            </a:r>
+            <a:r>
+              <a:rPr lang="de-DE" sz="1400" strike="sngStrike" dirty="0">
+                <a:solidFill>
+                  <a:schemeClr val="tx1"/>
+                </a:solidFill>
+              </a:rPr>
+              <a:t> will </a:t>
+            </a:r>
+            <a:r>
+              <a:rPr lang="de-DE" sz="1400" strike="sngStrike" dirty="0" err="1">
+                <a:solidFill>
+                  <a:schemeClr val="tx1"/>
+                </a:solidFill>
+              </a:rPr>
+              <a:t>be</a:t>
+            </a:r>
+            <a:r>
+              <a:rPr lang="de-DE" sz="1400" strike="sngStrike" dirty="0">
+                <a:solidFill>
+                  <a:schemeClr val="tx1"/>
+                </a:solidFill>
+              </a:rPr>
+              <a:t> </a:t>
+            </a:r>
+            <a:r>
+              <a:rPr lang="de-DE" sz="1400" strike="sngStrike" dirty="0" err="1">
+                <a:solidFill>
+                  <a:schemeClr val="tx1"/>
+                </a:solidFill>
+              </a:rPr>
+              <a:t>automatized</a:t>
+            </a:r>
+            <a:r>
+              <a:rPr lang="de-DE" sz="1400" strike="sngStrike" dirty="0">
+                <a:solidFill>
+                  <a:schemeClr val="tx1"/>
+                </a:solidFill>
+              </a:rPr>
+              <a:t> </a:t>
+            </a:r>
+            <a:r>
+              <a:rPr lang="de-DE" sz="1400" strike="sngStrike" dirty="0" err="1">
+                <a:solidFill>
+                  <a:schemeClr val="tx1"/>
+                </a:solidFill>
+              </a:rPr>
+              <a:t>later</a:t>
+            </a:r>
+            <a:r>
+              <a:rPr lang="de-DE" sz="1400" strike="sngStrike" dirty="0">
+                <a:solidFill>
+                  <a:schemeClr val="tx1"/>
+                </a:solidFill>
+              </a:rPr>
+              <a:t> </a:t>
+            </a:r>
+            <a:r>
+              <a:rPr lang="de-DE" sz="1400" strike="sngStrike" dirty="0" err="1">
+                <a:solidFill>
+                  <a:schemeClr val="tx1"/>
+                </a:solidFill>
+              </a:rPr>
+              <a:t>when</a:t>
+            </a:r>
+            <a:r>
+              <a:rPr lang="de-DE" sz="1400" strike="sngStrike" dirty="0">
+                <a:solidFill>
+                  <a:schemeClr val="tx1"/>
+                </a:solidFill>
+              </a:rPr>
+              <a:t> </a:t>
+            </a:r>
+            <a:r>
+              <a:rPr lang="de-DE" sz="1400" strike="sngStrike" dirty="0" err="1">
+                <a:solidFill>
+                  <a:schemeClr val="tx1"/>
+                </a:solidFill>
+              </a:rPr>
+              <a:t>we</a:t>
+            </a:r>
+            <a:r>
+              <a:rPr lang="de-DE" sz="1400" strike="sngStrike" dirty="0">
+                <a:solidFill>
+                  <a:schemeClr val="tx1"/>
+                </a:solidFill>
+              </a:rPr>
+              <a:t> </a:t>
+            </a:r>
+            <a:r>
+              <a:rPr lang="de-DE" sz="1400" strike="sngStrike" dirty="0" err="1">
+                <a:solidFill>
+                  <a:schemeClr val="tx1"/>
+                </a:solidFill>
+              </a:rPr>
+              <a:t>have</a:t>
+            </a:r>
+            <a:r>
+              <a:rPr lang="de-DE" sz="1400" strike="sngStrike" dirty="0">
+                <a:solidFill>
+                  <a:schemeClr val="tx1"/>
+                </a:solidFill>
+              </a:rPr>
+              <a:t> different </a:t>
+            </a:r>
+            <a:r>
+              <a:rPr lang="de-DE" sz="1400" strike="sngStrike" dirty="0" err="1">
+                <a:solidFill>
+                  <a:schemeClr val="tx1"/>
+                </a:solidFill>
+              </a:rPr>
+              <a:t>layout</a:t>
+            </a:r>
+            <a:r>
+              <a:rPr lang="de-DE" sz="1400" strike="sngStrike" dirty="0">
+                <a:solidFill>
+                  <a:schemeClr val="tx1"/>
+                </a:solidFill>
+              </a:rPr>
+              <a:t> </a:t>
+            </a:r>
+            <a:r>
+              <a:rPr lang="de-DE" sz="1400" strike="sngStrike" dirty="0" err="1">
+                <a:solidFill>
+                  <a:schemeClr val="tx1"/>
+                </a:solidFill>
+              </a:rPr>
+              <a:t>ideas</a:t>
+            </a:r>
+            <a:endParaRPr lang="de-DE" sz="1400" strike="sngStrike" dirty="0">
+              <a:solidFill>
+                <a:schemeClr val="tx1"/>
+              </a:solidFill>
+            </a:endParaRPr>
+          </a:p>
+          <a:p>
+            <a:pPr marL="342900" indent="-342900">
+              <a:buFont typeface="+mj-lt"/>
+              <a:buAutoNum type="arabicPeriod"/>
+            </a:pPr>
+            <a:r>
+              <a:rPr lang="de-DE" sz="1400" strike="sngStrike" dirty="0" err="1">
+                <a:solidFill>
+                  <a:schemeClr val="tx1"/>
+                </a:solidFill>
+              </a:rPr>
+              <a:t>naming</a:t>
+            </a:r>
+            <a:r>
+              <a:rPr lang="de-DE" sz="1400" strike="sngStrike" dirty="0">
+                <a:solidFill>
+                  <a:schemeClr val="tx1"/>
+                </a:solidFill>
+              </a:rPr>
+              <a:t> and README </a:t>
+            </a:r>
+            <a:r>
+              <a:rPr lang="de-DE" sz="1400" strike="sngStrike" dirty="0" err="1">
+                <a:solidFill>
+                  <a:schemeClr val="tx1"/>
+                </a:solidFill>
+              </a:rPr>
+              <a:t>files</a:t>
+            </a:r>
+            <a:r>
+              <a:rPr lang="de-DE" sz="1400" strike="sngStrike" dirty="0">
+                <a:solidFill>
+                  <a:schemeClr val="tx1"/>
+                </a:solidFill>
+              </a:rPr>
+              <a:t> </a:t>
+            </a:r>
+            <a:r>
+              <a:rPr lang="de-DE" sz="1400" strike="sngStrike" dirty="0" err="1">
+                <a:solidFill>
+                  <a:schemeClr val="tx1"/>
+                </a:solidFill>
+              </a:rPr>
+              <a:t>should</a:t>
+            </a:r>
+            <a:r>
+              <a:rPr lang="de-DE" sz="1400" strike="sngStrike" dirty="0">
+                <a:solidFill>
+                  <a:schemeClr val="tx1"/>
+                </a:solidFill>
+              </a:rPr>
+              <a:t> </a:t>
+            </a:r>
+            <a:r>
+              <a:rPr lang="de-DE" sz="1400" strike="sngStrike" dirty="0" err="1">
+                <a:solidFill>
+                  <a:schemeClr val="tx1"/>
+                </a:solidFill>
+              </a:rPr>
+              <a:t>be</a:t>
+            </a:r>
+            <a:r>
+              <a:rPr lang="de-DE" sz="1400" strike="sngStrike" dirty="0">
+                <a:solidFill>
+                  <a:schemeClr val="tx1"/>
+                </a:solidFill>
+              </a:rPr>
+              <a:t> </a:t>
+            </a:r>
+            <a:r>
+              <a:rPr lang="de-DE" sz="1400" strike="sngStrike" dirty="0" err="1">
+                <a:solidFill>
+                  <a:schemeClr val="tx1"/>
+                </a:solidFill>
+              </a:rPr>
+              <a:t>done</a:t>
+            </a:r>
+            <a:r>
+              <a:rPr lang="de-DE" sz="1400" strike="sngStrike" dirty="0">
+                <a:solidFill>
+                  <a:schemeClr val="tx1"/>
+                </a:solidFill>
+              </a:rPr>
+              <a:t> like MUSIC</a:t>
+            </a:r>
+          </a:p>
+          <a:p>
+            <a:pPr marL="342900" indent="-342900">
+              <a:buFont typeface="+mj-lt"/>
+              <a:buAutoNum type="arabicPeriod"/>
+            </a:pPr>
+            <a:r>
+              <a:rPr lang="de-DE" sz="1400" strike="sngStrike" dirty="0" err="1">
+                <a:solidFill>
+                  <a:schemeClr val="tx1"/>
+                </a:solidFill>
+              </a:rPr>
+              <a:t>add</a:t>
+            </a:r>
+            <a:r>
+              <a:rPr lang="de-DE" sz="1400" strike="sngStrike" dirty="0">
+                <a:solidFill>
+                  <a:schemeClr val="tx1"/>
+                </a:solidFill>
+              </a:rPr>
+              <a:t> </a:t>
+            </a:r>
+            <a:r>
+              <a:rPr lang="de-DE" sz="1400" strike="sngStrike" dirty="0" err="1">
+                <a:solidFill>
+                  <a:schemeClr val="tx1"/>
+                </a:solidFill>
+              </a:rPr>
+              <a:t>set</a:t>
+            </a:r>
+            <a:r>
+              <a:rPr lang="de-DE" sz="1400" strike="sngStrike" dirty="0">
+                <a:solidFill>
+                  <a:schemeClr val="tx1"/>
+                </a:solidFill>
+              </a:rPr>
+              <a:t> </a:t>
+            </a:r>
+            <a:r>
+              <a:rPr lang="de-DE" sz="1400" strike="sngStrike" dirty="0" err="1">
+                <a:solidFill>
+                  <a:schemeClr val="tx1"/>
+                </a:solidFill>
+              </a:rPr>
+              <a:t>button</a:t>
+            </a:r>
+            <a:r>
+              <a:rPr lang="de-DE" sz="1400" strike="sngStrike" dirty="0">
+                <a:solidFill>
+                  <a:schemeClr val="tx1"/>
+                </a:solidFill>
+              </a:rPr>
+              <a:t> </a:t>
+            </a:r>
+            <a:r>
+              <a:rPr lang="de-DE" sz="1400" strike="sngStrike" dirty="0" err="1">
+                <a:solidFill>
+                  <a:schemeClr val="tx1"/>
+                </a:solidFill>
+              </a:rPr>
+              <a:t>for</a:t>
+            </a:r>
+            <a:r>
+              <a:rPr lang="de-DE" sz="1400" strike="sngStrike" dirty="0">
+                <a:solidFill>
+                  <a:schemeClr val="tx1"/>
+                </a:solidFill>
+              </a:rPr>
+              <a:t> </a:t>
+            </a:r>
+            <a:r>
+              <a:rPr lang="de-DE" sz="1400" strike="sngStrike" dirty="0" err="1">
+                <a:solidFill>
+                  <a:schemeClr val="tx1"/>
+                </a:solidFill>
+              </a:rPr>
+              <a:t>scifi</a:t>
+            </a:r>
+            <a:r>
+              <a:rPr lang="de-DE" sz="1400" strike="sngStrike" dirty="0">
+                <a:solidFill>
+                  <a:schemeClr val="tx1"/>
+                </a:solidFill>
+              </a:rPr>
+              <a:t> </a:t>
+            </a:r>
+            <a:r>
+              <a:rPr lang="de-DE" sz="1400" strike="sngStrike" dirty="0" err="1">
+                <a:solidFill>
+                  <a:schemeClr val="tx1"/>
+                </a:solidFill>
+              </a:rPr>
+              <a:t>bias</a:t>
+            </a:r>
+            <a:r>
+              <a:rPr lang="de-DE" sz="1400" strike="sngStrike" dirty="0">
+                <a:solidFill>
+                  <a:schemeClr val="tx1"/>
+                </a:solidFill>
+              </a:rPr>
+              <a:t> </a:t>
+            </a:r>
+            <a:r>
+              <a:rPr lang="de-DE" sz="1400" strike="sngStrike" dirty="0" err="1">
+                <a:solidFill>
+                  <a:schemeClr val="tx1"/>
+                </a:solidFill>
+              </a:rPr>
+              <a:t>set</a:t>
+            </a:r>
+            <a:endParaRPr lang="de-DE" sz="1400" strike="sngStrike" dirty="0">
+              <a:solidFill>
+                <a:schemeClr val="tx1"/>
+              </a:solidFill>
+            </a:endParaRPr>
+          </a:p>
+          <a:p>
+            <a:pPr marL="342900" indent="-342900">
+              <a:buFont typeface="+mj-lt"/>
+              <a:buAutoNum type="arabicPeriod"/>
+            </a:pPr>
+            <a:r>
+              <a:rPr lang="de-DE" sz="1400" strike="sngStrike" dirty="0" err="1">
+                <a:solidFill>
+                  <a:schemeClr val="tx1"/>
+                </a:solidFill>
+              </a:rPr>
+              <a:t>meet</a:t>
+            </a:r>
+            <a:r>
+              <a:rPr lang="de-DE" sz="1400" strike="sngStrike" dirty="0">
+                <a:solidFill>
+                  <a:schemeClr val="tx1"/>
+                </a:solidFill>
+              </a:rPr>
+              <a:t> </a:t>
+            </a:r>
+            <a:r>
+              <a:rPr lang="de-DE" sz="1400" strike="sngStrike" dirty="0" err="1">
+                <a:solidFill>
+                  <a:schemeClr val="tx1"/>
+                </a:solidFill>
+              </a:rPr>
+              <a:t>with</a:t>
+            </a:r>
+            <a:r>
+              <a:rPr lang="de-DE" sz="1400" strike="sngStrike" dirty="0">
+                <a:solidFill>
+                  <a:schemeClr val="tx1"/>
+                </a:solidFill>
+              </a:rPr>
+              <a:t> Irakli </a:t>
+            </a:r>
+            <a:r>
+              <a:rPr lang="de-DE" sz="1400" strike="sngStrike" dirty="0" err="1">
+                <a:solidFill>
+                  <a:schemeClr val="tx1"/>
+                </a:solidFill>
+              </a:rPr>
+              <a:t>talk</a:t>
+            </a:r>
+            <a:r>
+              <a:rPr lang="de-DE" sz="1400" strike="sngStrike" dirty="0">
+                <a:solidFill>
+                  <a:schemeClr val="tx1"/>
+                </a:solidFill>
+              </a:rPr>
+              <a:t> </a:t>
+            </a:r>
+            <a:r>
+              <a:rPr lang="de-DE" sz="1400" strike="sngStrike" dirty="0" err="1">
+                <a:solidFill>
+                  <a:schemeClr val="tx1"/>
+                </a:solidFill>
+              </a:rPr>
+              <a:t>about</a:t>
+            </a:r>
+            <a:r>
+              <a:rPr lang="de-DE" sz="1400" strike="sngStrike" dirty="0">
+                <a:solidFill>
+                  <a:schemeClr val="tx1"/>
+                </a:solidFill>
+              </a:rPr>
+              <a:t> </a:t>
+            </a:r>
+            <a:r>
+              <a:rPr lang="de-DE" sz="1400" strike="sngStrike" dirty="0" err="1">
+                <a:solidFill>
+                  <a:schemeClr val="tx1"/>
+                </a:solidFill>
+              </a:rPr>
+              <a:t>feedbacks</a:t>
+            </a:r>
+            <a:r>
+              <a:rPr lang="de-DE" sz="1400" strike="sngStrike" dirty="0">
+                <a:solidFill>
+                  <a:schemeClr val="tx1"/>
+                </a:solidFill>
+              </a:rPr>
+              <a:t> </a:t>
+            </a:r>
+            <a:r>
+              <a:rPr lang="de-DE" sz="1400" dirty="0">
+                <a:solidFill>
+                  <a:schemeClr val="tx1"/>
+                </a:solidFill>
+              </a:rPr>
+              <a:t>(Irakli </a:t>
+            </a:r>
+            <a:r>
+              <a:rPr lang="de-DE" sz="1400" dirty="0" err="1">
+                <a:solidFill>
+                  <a:schemeClr val="tx1"/>
+                </a:solidFill>
+              </a:rPr>
+              <a:t>two</a:t>
+            </a:r>
+            <a:r>
+              <a:rPr lang="de-DE" sz="1400" dirty="0">
+                <a:solidFill>
+                  <a:schemeClr val="tx1"/>
+                </a:solidFill>
+              </a:rPr>
+              <a:t> </a:t>
+            </a:r>
+            <a:r>
+              <a:rPr lang="de-DE" sz="1400" dirty="0" err="1">
+                <a:solidFill>
+                  <a:schemeClr val="tx1"/>
+                </a:solidFill>
+              </a:rPr>
+              <a:t>weeks</a:t>
+            </a:r>
+            <a:r>
+              <a:rPr lang="de-DE" sz="1400" dirty="0">
+                <a:solidFill>
+                  <a:schemeClr val="tx1"/>
+                </a:solidFill>
+              </a:rPr>
+              <a:t> </a:t>
+            </a:r>
+            <a:r>
+              <a:rPr lang="de-DE" sz="1400" dirty="0" err="1">
+                <a:solidFill>
+                  <a:schemeClr val="tx1"/>
+                </a:solidFill>
+              </a:rPr>
+              <a:t>absence,told</a:t>
+            </a:r>
+            <a:r>
+              <a:rPr lang="de-DE" sz="1400" dirty="0">
+                <a:solidFill>
+                  <a:schemeClr val="tx1"/>
+                </a:solidFill>
+              </a:rPr>
+              <a:t> </a:t>
+            </a:r>
+            <a:r>
+              <a:rPr lang="de-DE" sz="1400" dirty="0" err="1">
+                <a:solidFill>
+                  <a:schemeClr val="tx1"/>
+                </a:solidFill>
+              </a:rPr>
+              <a:t>me</a:t>
+            </a:r>
+            <a:r>
+              <a:rPr lang="de-DE" sz="1400" dirty="0">
+                <a:solidFill>
+                  <a:schemeClr val="tx1"/>
+                </a:solidFill>
+              </a:rPr>
+              <a:t> </a:t>
+            </a:r>
+            <a:r>
+              <a:rPr lang="de-DE" sz="1400" dirty="0" err="1">
+                <a:solidFill>
+                  <a:schemeClr val="tx1"/>
+                </a:solidFill>
+              </a:rPr>
+              <a:t>focusing</a:t>
+            </a:r>
+            <a:r>
+              <a:rPr lang="de-DE" sz="1400" dirty="0">
+                <a:solidFill>
+                  <a:schemeClr val="tx1"/>
+                </a:solidFill>
+              </a:rPr>
+              <a:t> on EPICS </a:t>
+            </a:r>
+            <a:r>
+              <a:rPr lang="de-DE" sz="1400" dirty="0" err="1">
+                <a:solidFill>
+                  <a:schemeClr val="tx1"/>
+                </a:solidFill>
+              </a:rPr>
+              <a:t>system</a:t>
+            </a:r>
+            <a:r>
+              <a:rPr lang="de-DE" sz="1400" dirty="0">
+                <a:solidFill>
+                  <a:schemeClr val="tx1"/>
+                </a:solidFill>
+              </a:rPr>
+              <a:t> </a:t>
+            </a:r>
+            <a:r>
+              <a:rPr lang="de-DE" sz="1400" dirty="0" err="1">
+                <a:solidFill>
+                  <a:schemeClr val="tx1"/>
+                </a:solidFill>
+              </a:rPr>
+              <a:t>fundamentals</a:t>
+            </a:r>
+            <a:r>
+              <a:rPr lang="de-DE" sz="1400" dirty="0">
+                <a:solidFill>
+                  <a:schemeClr val="tx1"/>
+                </a:solidFill>
+              </a:rPr>
+              <a:t> </a:t>
+            </a:r>
+            <a:r>
+              <a:rPr lang="de-DE" sz="1400" dirty="0" err="1">
+                <a:solidFill>
+                  <a:schemeClr val="tx1"/>
+                </a:solidFill>
+              </a:rPr>
+              <a:t>for</a:t>
+            </a:r>
+            <a:r>
+              <a:rPr lang="de-DE" sz="1400" dirty="0">
+                <a:solidFill>
+                  <a:schemeClr val="tx1"/>
+                </a:solidFill>
+              </a:rPr>
+              <a:t> </a:t>
+            </a:r>
+            <a:r>
+              <a:rPr lang="de-DE" sz="1400" dirty="0" err="1">
+                <a:solidFill>
+                  <a:schemeClr val="tx1"/>
+                </a:solidFill>
+              </a:rPr>
+              <a:t>this</a:t>
+            </a:r>
+            <a:r>
+              <a:rPr lang="de-DE" sz="1400" dirty="0">
+                <a:solidFill>
+                  <a:schemeClr val="tx1"/>
+                </a:solidFill>
+              </a:rPr>
+              <a:t> </a:t>
+            </a:r>
+            <a:r>
+              <a:rPr lang="de-DE" sz="1400" dirty="0" err="1">
+                <a:solidFill>
+                  <a:schemeClr val="tx1"/>
+                </a:solidFill>
+              </a:rPr>
+              <a:t>period</a:t>
+            </a:r>
+            <a:r>
+              <a:rPr lang="de-DE" sz="1400" dirty="0">
+                <a:solidFill>
+                  <a:schemeClr val="tx1"/>
+                </a:solidFill>
+              </a:rPr>
+              <a:t>)</a:t>
+            </a:r>
+            <a:endParaRPr lang="de-DE" sz="1400" strike="sngStrike" dirty="0">
+              <a:solidFill>
+                <a:schemeClr val="tx1"/>
+              </a:solidFill>
+            </a:endParaRPr>
+          </a:p>
+          <a:p>
+            <a:pPr marL="342900" indent="-342900">
+              <a:buFont typeface="+mj-lt"/>
+              <a:buAutoNum type="arabicPeriod"/>
+            </a:pPr>
+            <a:endParaRPr lang="de-DE" sz="1400" dirty="0"/>
+          </a:p>
+          <a:p>
+            <a:pPr marL="0" indent="0">
+              <a:buNone/>
+            </a:pPr>
+            <a:r>
+              <a:rPr lang="de-DE" b="1" dirty="0"/>
+              <a:t>Questions / </a:t>
+            </a:r>
+            <a:r>
+              <a:rPr lang="de-DE" b="1" dirty="0" err="1"/>
+              <a:t>Ideas</a:t>
+            </a:r>
+            <a:endParaRPr lang="de-DE" b="1" dirty="0"/>
+          </a:p>
+          <a:p>
+            <a:pPr marL="342900" indent="-342900">
+              <a:buFont typeface="+mj-lt"/>
+              <a:buAutoNum type="arabicPeriod"/>
+            </a:pPr>
+            <a:r>
+              <a:rPr lang="de-DE" sz="1400" dirty="0" err="1"/>
+              <a:t>multistate</a:t>
+            </a:r>
+            <a:r>
+              <a:rPr lang="de-DE" sz="1400" dirty="0"/>
+              <a:t> </a:t>
+            </a:r>
+            <a:r>
+              <a:rPr lang="de-DE" sz="1400" dirty="0" err="1"/>
+              <a:t>leds</a:t>
+            </a:r>
+            <a:r>
+              <a:rPr lang="de-DE" sz="1400" dirty="0"/>
+              <a:t> </a:t>
+            </a:r>
+            <a:r>
+              <a:rPr lang="de-DE" sz="1400" dirty="0" err="1"/>
+              <a:t>make</a:t>
+            </a:r>
+            <a:r>
+              <a:rPr lang="de-DE" sz="1400" dirty="0"/>
+              <a:t> </a:t>
+            </a:r>
+            <a:r>
+              <a:rPr lang="de-DE" sz="1400" dirty="0" err="1"/>
+              <a:t>error</a:t>
+            </a:r>
+            <a:r>
+              <a:rPr lang="de-DE" sz="1400" dirty="0"/>
+              <a:t>, </a:t>
+            </a:r>
+            <a:r>
+              <a:rPr lang="de-DE" sz="1400" dirty="0" err="1"/>
+              <a:t>warning</a:t>
+            </a:r>
+            <a:r>
+              <a:rPr lang="de-DE" sz="1400" dirty="0"/>
+              <a:t>, ok</a:t>
+            </a:r>
+          </a:p>
+          <a:p>
+            <a:pPr marL="342900" indent="-342900">
+              <a:buFont typeface="+mj-lt"/>
+              <a:buAutoNum type="arabicPeriod"/>
+            </a:pPr>
+            <a:r>
+              <a:rPr lang="de-DE" sz="1400" dirty="0" err="1"/>
+              <a:t>for</a:t>
+            </a:r>
+            <a:r>
+              <a:rPr lang="de-DE" sz="1400" dirty="0"/>
+              <a:t> </a:t>
+            </a:r>
+            <a:r>
+              <a:rPr lang="de-DE" sz="1400" dirty="0" err="1"/>
+              <a:t>plsci</a:t>
+            </a:r>
+            <a:r>
+              <a:rPr lang="de-DE" sz="1400" dirty="0"/>
+              <a:t> </a:t>
+            </a:r>
+            <a:r>
+              <a:rPr lang="de-DE" sz="1400" dirty="0" err="1"/>
+              <a:t>it</a:t>
+            </a:r>
+            <a:r>
+              <a:rPr lang="de-DE" sz="1400" dirty="0"/>
+              <a:t> </a:t>
+            </a:r>
+            <a:r>
+              <a:rPr lang="de-DE" sz="1400" dirty="0" err="1"/>
+              <a:t>may</a:t>
+            </a:r>
+            <a:r>
+              <a:rPr lang="de-DE" sz="1400" dirty="0"/>
+              <a:t> </a:t>
+            </a:r>
+            <a:r>
+              <a:rPr lang="de-DE" sz="1400" dirty="0" err="1"/>
+              <a:t>be</a:t>
+            </a:r>
+            <a:r>
+              <a:rPr lang="de-DE" sz="1400" dirty="0"/>
+              <a:t> </a:t>
+            </a:r>
+            <a:r>
+              <a:rPr lang="de-DE" sz="1400" dirty="0" err="1"/>
+              <a:t>used</a:t>
+            </a:r>
+            <a:r>
+              <a:rPr lang="de-DE" sz="1400" dirty="0"/>
+              <a:t> tank/</a:t>
+            </a:r>
+            <a:r>
+              <a:rPr lang="de-DE" sz="1400" dirty="0" err="1"/>
+              <a:t>progress</a:t>
+            </a:r>
+            <a:r>
+              <a:rPr lang="de-DE" sz="1400" dirty="0"/>
+              <a:t> bar </a:t>
+            </a:r>
+            <a:r>
+              <a:rPr lang="de-DE" sz="1400" dirty="0" err="1"/>
+              <a:t>for</a:t>
+            </a:r>
+            <a:r>
+              <a:rPr lang="de-DE" sz="1400" dirty="0"/>
+              <a:t> HV_I_RBV</a:t>
+            </a:r>
+          </a:p>
+          <a:p>
+            <a:pPr marL="300038" lvl="1" indent="0">
+              <a:buNone/>
+            </a:pPr>
+            <a:endParaRPr lang="de-DE" sz="1000" dirty="0"/>
+          </a:p>
+        </p:txBody>
+      </p:sp>
+    </p:spTree>
+    <p:extLst>
+      <p:ext uri="{BB962C8B-B14F-4D97-AF65-F5344CB8AC3E}">
+        <p14:creationId xmlns:p14="http://schemas.microsoft.com/office/powerpoint/2010/main" val="2814592011"/>
       </p:ext>
     </p:extLst>
   </p:cSld>

</xml_diff>

<commit_message>
MUSIC - Status info box added
</commit_message>
<xml_diff>
--- a/CSS_examples/Documentation && Report/CSS works.pptx
+++ b/CSS_examples/Documentation && Report/CSS works.pptx
@@ -5,10 +5,10 @@
     <p:sldMasterId id="2147483648" r:id="rId1"/>
   </p:sldMasterIdLst>
   <p:notesMasterIdLst>
-    <p:notesMasterId r:id="rId25"/>
+    <p:notesMasterId r:id="rId28"/>
   </p:notesMasterIdLst>
   <p:handoutMasterIdLst>
-    <p:handoutMasterId r:id="rId26"/>
+    <p:handoutMasterId r:id="rId29"/>
   </p:handoutMasterIdLst>
   <p:sldIdLst>
     <p:sldId id="256" r:id="rId2"/>
@@ -34,6 +34,9 @@
     <p:sldId id="276" r:id="rId22"/>
     <p:sldId id="277" r:id="rId23"/>
     <p:sldId id="278" r:id="rId24"/>
+    <p:sldId id="279" r:id="rId25"/>
+    <p:sldId id="280" r:id="rId26"/>
+    <p:sldId id="281" r:id="rId27"/>
   </p:sldIdLst>
   <p:sldSz cx="9144000" cy="5143500" type="screen16x9"/>
   <p:notesSz cx="7104063" cy="10234613"/>
@@ -233,7 +236,7 @@
           <a:p>
             <a:fld id="{0B851660-0934-124D-A4B3-496C7F320307}" type="datetimeFigureOut">
               <a:rPr lang="de-DE" smtClean="0"/>
-              <a:t>27.08.2026</a:t>
+              <a:t>02.09.2026</a:t>
             </a:fld>
             <a:endParaRPr lang="de-DE"/>
           </a:p>
@@ -399,7 +402,7 @@
           <a:p>
             <a:fld id="{98C828EF-C252-394A-93BF-1C478CFA0896}" type="datetimeFigureOut">
               <a:rPr lang="de-DE" smtClean="0"/>
-              <a:t>27.08.2026</a:t>
+              <a:t>02.09.2026</a:t>
             </a:fld>
             <a:endParaRPr lang="de-DE"/>
           </a:p>
@@ -11530,6 +11533,1386 @@
     <p:extLst>
       <p:ext uri="{BB962C8B-B14F-4D97-AF65-F5344CB8AC3E}">
         <p14:creationId xmlns:p14="http://schemas.microsoft.com/office/powerpoint/2010/main" val="2814592011"/>
+      </p:ext>
+    </p:extLst>
+  </p:cSld>
+  <p:clrMapOvr>
+    <a:masterClrMapping/>
+  </p:clrMapOvr>
+</p:sld>
+</file>
+
+<file path=ppt/slides/slide24.xml><?xml version="1.0" encoding="utf-8"?>
+<p:sld xmlns:a="http://schemas.openxmlformats.org/drawingml/2006/main" xmlns:r="http://schemas.openxmlformats.org/officeDocument/2006/relationships" xmlns:p="http://schemas.openxmlformats.org/presentationml/2006/main">
+  <p:cSld>
+    <p:spTree>
+      <p:nvGrpSpPr>
+        <p:cNvPr id="1" name=""/>
+        <p:cNvGrpSpPr/>
+        <p:nvPr/>
+      </p:nvGrpSpPr>
+      <p:grpSpPr>
+        <a:xfrm>
+          <a:off x="0" y="0"/>
+          <a:ext cx="0" cy="0"/>
+          <a:chOff x="0" y="0"/>
+          <a:chExt cx="0" cy="0"/>
+        </a:xfrm>
+      </p:grpSpPr>
+      <p:sp>
+        <p:nvSpPr>
+          <p:cNvPr id="2" name="Title 1">
+            <a:extLst>
+              <a:ext uri="{FF2B5EF4-FFF2-40B4-BE49-F238E27FC236}">
+                <a16:creationId xmlns:a16="http://schemas.microsoft.com/office/drawing/2014/main" id="{C4F020AE-CD6F-4C87-8B44-2242F3095430}"/>
+              </a:ext>
+            </a:extLst>
+          </p:cNvPr>
+          <p:cNvSpPr>
+            <a:spLocks noGrp="1"/>
+          </p:cNvSpPr>
+          <p:nvPr>
+            <p:ph type="title"/>
+          </p:nvPr>
+        </p:nvSpPr>
+        <p:spPr/>
+        <p:txBody>
+          <a:bodyPr/>
+          <a:lstStyle/>
+          <a:p>
+            <a:r>
+              <a:rPr lang="de-DE" dirty="0"/>
+              <a:t>Report 26.08.31</a:t>
+            </a:r>
+          </a:p>
+        </p:txBody>
+      </p:sp>
+      <p:sp>
+        <p:nvSpPr>
+          <p:cNvPr id="4" name="Content Placeholder 2">
+            <a:extLst>
+              <a:ext uri="{FF2B5EF4-FFF2-40B4-BE49-F238E27FC236}">
+                <a16:creationId xmlns:a16="http://schemas.microsoft.com/office/drawing/2014/main" id="{FA77772D-0DBC-49CF-A5F5-2F8530CE8539}"/>
+              </a:ext>
+            </a:extLst>
+          </p:cNvPr>
+          <p:cNvSpPr>
+            <a:spLocks noGrp="1"/>
+          </p:cNvSpPr>
+          <p:nvPr>
+            <p:ph idx="1"/>
+          </p:nvPr>
+        </p:nvSpPr>
+        <p:spPr>
+          <a:xfrm>
+            <a:off x="317500" y="1087438"/>
+            <a:ext cx="8420100" cy="3678237"/>
+          </a:xfrm>
+        </p:spPr>
+        <p:txBody>
+          <a:bodyPr/>
+          <a:lstStyle/>
+          <a:p>
+            <a:pPr marL="0" indent="0">
+              <a:buNone/>
+            </a:pPr>
+            <a:r>
+              <a:rPr lang="de-DE" b="1" dirty="0" err="1"/>
+              <a:t>Suggested</a:t>
+            </a:r>
+            <a:endParaRPr lang="de-DE" b="1" dirty="0"/>
+          </a:p>
+          <a:p>
+            <a:pPr marL="342900" indent="-342900">
+              <a:buFont typeface="+mj-lt"/>
+              <a:buAutoNum type="arabicPeriod"/>
+            </a:pPr>
+            <a:r>
+              <a:rPr lang="de-DE" sz="1400" dirty="0" err="1">
+                <a:solidFill>
+                  <a:srgbClr val="FF0000"/>
+                </a:solidFill>
+              </a:rPr>
+              <a:t>to</a:t>
+            </a:r>
+            <a:r>
+              <a:rPr lang="de-DE" sz="1400" dirty="0">
+                <a:solidFill>
+                  <a:srgbClr val="FF0000"/>
+                </a:solidFill>
+              </a:rPr>
+              <a:t> </a:t>
+            </a:r>
+            <a:r>
+              <a:rPr lang="de-DE" sz="1400" dirty="0" err="1">
+                <a:solidFill>
+                  <a:srgbClr val="FF0000"/>
+                </a:solidFill>
+              </a:rPr>
+              <a:t>think</a:t>
+            </a:r>
+            <a:r>
+              <a:rPr lang="de-DE" sz="1400" dirty="0">
+                <a:solidFill>
+                  <a:srgbClr val="FF0000"/>
+                </a:solidFill>
+              </a:rPr>
+              <a:t> </a:t>
+            </a:r>
+            <a:r>
+              <a:rPr lang="de-DE" sz="1400" dirty="0" err="1">
+                <a:solidFill>
+                  <a:srgbClr val="FF0000"/>
+                </a:solidFill>
+              </a:rPr>
+              <a:t>click</a:t>
+            </a:r>
+            <a:r>
+              <a:rPr lang="de-DE" sz="1400" dirty="0">
+                <a:solidFill>
+                  <a:srgbClr val="FF0000"/>
+                </a:solidFill>
+              </a:rPr>
+              <a:t> a </a:t>
+            </a:r>
+            <a:r>
+              <a:rPr lang="de-DE" sz="1400" dirty="0" err="1">
+                <a:solidFill>
+                  <a:srgbClr val="FF0000"/>
+                </a:solidFill>
+              </a:rPr>
+              <a:t>button</a:t>
+            </a:r>
+            <a:r>
+              <a:rPr lang="de-DE" sz="1400" dirty="0">
+                <a:solidFill>
+                  <a:srgbClr val="FF0000"/>
+                </a:solidFill>
+              </a:rPr>
+              <a:t> </a:t>
+            </a:r>
+            <a:r>
+              <a:rPr lang="de-DE" sz="1400" dirty="0" err="1">
+                <a:solidFill>
+                  <a:srgbClr val="FF0000"/>
+                </a:solidFill>
+              </a:rPr>
+              <a:t>to</a:t>
+            </a:r>
+            <a:r>
+              <a:rPr lang="de-DE" sz="1400" dirty="0">
+                <a:solidFill>
+                  <a:srgbClr val="FF0000"/>
+                </a:solidFill>
+              </a:rPr>
+              <a:t> open a </a:t>
+            </a:r>
+            <a:r>
+              <a:rPr lang="de-DE" sz="1400" dirty="0" err="1">
+                <a:solidFill>
+                  <a:srgbClr val="FF0000"/>
+                </a:solidFill>
+              </a:rPr>
+              <a:t>new</a:t>
+            </a:r>
+            <a:r>
+              <a:rPr lang="de-DE" sz="1400" dirty="0">
+                <a:solidFill>
+                  <a:srgbClr val="FF0000"/>
+                </a:solidFill>
+              </a:rPr>
+              <a:t> </a:t>
+            </a:r>
+            <a:r>
+              <a:rPr lang="de-DE" sz="1400" dirty="0" err="1">
+                <a:solidFill>
+                  <a:srgbClr val="FF0000"/>
+                </a:solidFill>
+              </a:rPr>
+              <a:t>tab</a:t>
+            </a:r>
+            <a:endParaRPr lang="de-DE" sz="1400" dirty="0">
+              <a:solidFill>
+                <a:srgbClr val="FF0000"/>
+              </a:solidFill>
+            </a:endParaRPr>
+          </a:p>
+          <a:p>
+            <a:pPr marL="342900" indent="-342900">
+              <a:buFont typeface="+mj-lt"/>
+              <a:buAutoNum type="arabicPeriod"/>
+            </a:pPr>
+            <a:r>
+              <a:rPr lang="de-DE" sz="1400" dirty="0" err="1"/>
+              <a:t>look</a:t>
+            </a:r>
+            <a:r>
+              <a:rPr lang="de-DE" sz="1400" dirty="0"/>
+              <a:t> </a:t>
+            </a:r>
+            <a:r>
+              <a:rPr lang="de-DE" sz="1400" dirty="0" err="1"/>
+              <a:t>the</a:t>
+            </a:r>
+            <a:r>
+              <a:rPr lang="de-DE" sz="1400" dirty="0"/>
+              <a:t> </a:t>
+            </a:r>
+            <a:r>
+              <a:rPr lang="de-DE" sz="1400" dirty="0" err="1"/>
+              <a:t>fundamentals</a:t>
+            </a:r>
+            <a:r>
+              <a:rPr lang="de-DE" sz="1400" dirty="0"/>
+              <a:t> </a:t>
+            </a:r>
+            <a:r>
+              <a:rPr lang="de-DE" sz="1400" dirty="0" err="1"/>
+              <a:t>of</a:t>
+            </a:r>
+            <a:r>
+              <a:rPr lang="de-DE" sz="1400" dirty="0"/>
+              <a:t> </a:t>
+            </a:r>
+            <a:r>
+              <a:rPr lang="de-DE" sz="1400"/>
+              <a:t>EPICS ?</a:t>
+            </a:r>
+            <a:endParaRPr lang="de-DE" sz="1400" dirty="0"/>
+          </a:p>
+          <a:p>
+            <a:pPr marL="342900" indent="-342900">
+              <a:buFont typeface="+mj-lt"/>
+              <a:buAutoNum type="arabicPeriod"/>
+            </a:pPr>
+            <a:endParaRPr lang="de-DE" sz="1400" dirty="0"/>
+          </a:p>
+          <a:p>
+            <a:pPr marL="342900" indent="-342900">
+              <a:buFont typeface="+mj-lt"/>
+              <a:buAutoNum type="arabicPeriod"/>
+            </a:pPr>
+            <a:endParaRPr lang="de-DE" sz="1400" dirty="0"/>
+          </a:p>
+          <a:p>
+            <a:pPr marL="342900" indent="-342900">
+              <a:buFont typeface="+mj-lt"/>
+              <a:buAutoNum type="arabicPeriod"/>
+            </a:pPr>
+            <a:endParaRPr lang="de-DE" sz="1400" dirty="0"/>
+          </a:p>
+          <a:p>
+            <a:pPr marL="342900" indent="-342900">
+              <a:buFont typeface="+mj-lt"/>
+              <a:buAutoNum type="arabicPeriod"/>
+            </a:pPr>
+            <a:endParaRPr lang="de-DE" sz="1400" dirty="0"/>
+          </a:p>
+          <a:p>
+            <a:pPr marL="342900" indent="-342900">
+              <a:buFont typeface="+mj-lt"/>
+              <a:buAutoNum type="arabicPeriod"/>
+            </a:pPr>
+            <a:endParaRPr lang="de-DE" sz="1400" dirty="0"/>
+          </a:p>
+          <a:p>
+            <a:pPr marL="0" indent="0">
+              <a:buNone/>
+            </a:pPr>
+            <a:endParaRPr lang="de-DE" sz="1400" dirty="0"/>
+          </a:p>
+          <a:p>
+            <a:pPr marL="0" indent="0">
+              <a:buNone/>
+            </a:pPr>
+            <a:r>
+              <a:rPr lang="de-DE" b="1" dirty="0"/>
+              <a:t>Questions / </a:t>
+            </a:r>
+            <a:r>
+              <a:rPr lang="de-DE" b="1" dirty="0" err="1"/>
+              <a:t>Ideas</a:t>
+            </a:r>
+            <a:endParaRPr lang="de-DE" b="1" dirty="0"/>
+          </a:p>
+          <a:p>
+            <a:pPr marL="342900" indent="-342900">
+              <a:buFont typeface="+mj-lt"/>
+              <a:buAutoNum type="arabicPeriod"/>
+            </a:pPr>
+            <a:r>
+              <a:rPr lang="de-DE" sz="1400" dirty="0" err="1"/>
+              <a:t>multistate</a:t>
+            </a:r>
+            <a:r>
+              <a:rPr lang="de-DE" sz="1400" dirty="0"/>
+              <a:t> </a:t>
+            </a:r>
+            <a:r>
+              <a:rPr lang="de-DE" sz="1400" dirty="0" err="1"/>
+              <a:t>leds</a:t>
+            </a:r>
+            <a:r>
+              <a:rPr lang="de-DE" sz="1400" dirty="0"/>
+              <a:t> </a:t>
+            </a:r>
+            <a:r>
+              <a:rPr lang="de-DE" sz="1400" dirty="0" err="1"/>
+              <a:t>make</a:t>
+            </a:r>
+            <a:r>
+              <a:rPr lang="de-DE" sz="1400" dirty="0"/>
+              <a:t> </a:t>
+            </a:r>
+            <a:r>
+              <a:rPr lang="de-DE" sz="1400" dirty="0" err="1"/>
+              <a:t>error</a:t>
+            </a:r>
+            <a:r>
+              <a:rPr lang="de-DE" sz="1400" dirty="0"/>
+              <a:t>, </a:t>
+            </a:r>
+            <a:r>
+              <a:rPr lang="de-DE" sz="1400" dirty="0" err="1"/>
+              <a:t>warning</a:t>
+            </a:r>
+            <a:r>
+              <a:rPr lang="de-DE" sz="1400" dirty="0"/>
+              <a:t>, ok</a:t>
+            </a:r>
+          </a:p>
+          <a:p>
+            <a:pPr marL="342900" indent="-342900">
+              <a:buFont typeface="+mj-lt"/>
+              <a:buAutoNum type="arabicPeriod"/>
+            </a:pPr>
+            <a:r>
+              <a:rPr lang="de-DE" sz="1400" dirty="0" err="1"/>
+              <a:t>for</a:t>
+            </a:r>
+            <a:r>
+              <a:rPr lang="de-DE" sz="1400" dirty="0"/>
+              <a:t> </a:t>
+            </a:r>
+            <a:r>
+              <a:rPr lang="de-DE" sz="1400" dirty="0" err="1"/>
+              <a:t>plsci</a:t>
+            </a:r>
+            <a:r>
+              <a:rPr lang="de-DE" sz="1400" dirty="0"/>
+              <a:t> </a:t>
+            </a:r>
+            <a:r>
+              <a:rPr lang="de-DE" sz="1400" dirty="0" err="1"/>
+              <a:t>it</a:t>
+            </a:r>
+            <a:r>
+              <a:rPr lang="de-DE" sz="1400" dirty="0"/>
+              <a:t> </a:t>
+            </a:r>
+            <a:r>
+              <a:rPr lang="de-DE" sz="1400" dirty="0" err="1"/>
+              <a:t>may</a:t>
+            </a:r>
+            <a:r>
+              <a:rPr lang="de-DE" sz="1400" dirty="0"/>
+              <a:t> </a:t>
+            </a:r>
+            <a:r>
+              <a:rPr lang="de-DE" sz="1400" dirty="0" err="1"/>
+              <a:t>be</a:t>
+            </a:r>
+            <a:r>
+              <a:rPr lang="de-DE" sz="1400" dirty="0"/>
+              <a:t> </a:t>
+            </a:r>
+            <a:r>
+              <a:rPr lang="de-DE" sz="1400" dirty="0" err="1"/>
+              <a:t>used</a:t>
+            </a:r>
+            <a:r>
+              <a:rPr lang="de-DE" sz="1400" dirty="0"/>
+              <a:t> tank/</a:t>
+            </a:r>
+            <a:r>
+              <a:rPr lang="de-DE" sz="1400" dirty="0" err="1"/>
+              <a:t>progress</a:t>
+            </a:r>
+            <a:r>
+              <a:rPr lang="de-DE" sz="1400" dirty="0"/>
+              <a:t> bar </a:t>
+            </a:r>
+            <a:r>
+              <a:rPr lang="de-DE" sz="1400" dirty="0" err="1"/>
+              <a:t>for</a:t>
+            </a:r>
+            <a:r>
+              <a:rPr lang="de-DE" sz="1400" dirty="0"/>
+              <a:t> HV_I_RBV</a:t>
+            </a:r>
+          </a:p>
+          <a:p>
+            <a:pPr marL="300038" lvl="1" indent="0">
+              <a:buNone/>
+            </a:pPr>
+            <a:endParaRPr lang="de-DE" sz="1000" dirty="0"/>
+          </a:p>
+        </p:txBody>
+      </p:sp>
+    </p:spTree>
+    <p:extLst>
+      <p:ext uri="{BB962C8B-B14F-4D97-AF65-F5344CB8AC3E}">
+        <p14:creationId xmlns:p14="http://schemas.microsoft.com/office/powerpoint/2010/main" val="3634685807"/>
+      </p:ext>
+    </p:extLst>
+  </p:cSld>
+  <p:clrMapOvr>
+    <a:masterClrMapping/>
+  </p:clrMapOvr>
+</p:sld>
+</file>
+
+<file path=ppt/slides/slide25.xml><?xml version="1.0" encoding="utf-8"?>
+<p:sld xmlns:a="http://schemas.openxmlformats.org/drawingml/2006/main" xmlns:r="http://schemas.openxmlformats.org/officeDocument/2006/relationships" xmlns:p="http://schemas.openxmlformats.org/presentationml/2006/main">
+  <p:cSld>
+    <p:spTree>
+      <p:nvGrpSpPr>
+        <p:cNvPr id="1" name=""/>
+        <p:cNvGrpSpPr/>
+        <p:nvPr/>
+      </p:nvGrpSpPr>
+      <p:grpSpPr>
+        <a:xfrm>
+          <a:off x="0" y="0"/>
+          <a:ext cx="0" cy="0"/>
+          <a:chOff x="0" y="0"/>
+          <a:chExt cx="0" cy="0"/>
+        </a:xfrm>
+      </p:grpSpPr>
+      <p:sp>
+        <p:nvSpPr>
+          <p:cNvPr id="2" name="Title 1">
+            <a:extLst>
+              <a:ext uri="{FF2B5EF4-FFF2-40B4-BE49-F238E27FC236}">
+                <a16:creationId xmlns:a16="http://schemas.microsoft.com/office/drawing/2014/main" id="{C4F020AE-CD6F-4C87-8B44-2242F3095430}"/>
+              </a:ext>
+            </a:extLst>
+          </p:cNvPr>
+          <p:cNvSpPr>
+            <a:spLocks noGrp="1"/>
+          </p:cNvSpPr>
+          <p:nvPr>
+            <p:ph type="title"/>
+          </p:nvPr>
+        </p:nvSpPr>
+        <p:spPr/>
+        <p:txBody>
+          <a:bodyPr/>
+          <a:lstStyle/>
+          <a:p>
+            <a:r>
+              <a:rPr lang="de-DE" dirty="0"/>
+              <a:t>Report 26.09.01</a:t>
+            </a:r>
+          </a:p>
+        </p:txBody>
+      </p:sp>
+      <p:sp>
+        <p:nvSpPr>
+          <p:cNvPr id="4" name="Content Placeholder 2">
+            <a:extLst>
+              <a:ext uri="{FF2B5EF4-FFF2-40B4-BE49-F238E27FC236}">
+                <a16:creationId xmlns:a16="http://schemas.microsoft.com/office/drawing/2014/main" id="{FA77772D-0DBC-49CF-A5F5-2F8530CE8539}"/>
+              </a:ext>
+            </a:extLst>
+          </p:cNvPr>
+          <p:cNvSpPr>
+            <a:spLocks noGrp="1"/>
+          </p:cNvSpPr>
+          <p:nvPr>
+            <p:ph idx="1"/>
+          </p:nvPr>
+        </p:nvSpPr>
+        <p:spPr>
+          <a:xfrm>
+            <a:off x="317500" y="1087438"/>
+            <a:ext cx="8420100" cy="3678237"/>
+          </a:xfrm>
+        </p:spPr>
+        <p:txBody>
+          <a:bodyPr/>
+          <a:lstStyle/>
+          <a:p>
+            <a:pPr marL="0" indent="0">
+              <a:buNone/>
+            </a:pPr>
+            <a:r>
+              <a:rPr lang="de-DE" b="1" dirty="0" err="1"/>
+              <a:t>Suggested</a:t>
+            </a:r>
+            <a:endParaRPr lang="de-DE" b="1" dirty="0"/>
+          </a:p>
+          <a:p>
+            <a:pPr marL="342900" indent="-342900">
+              <a:buFont typeface="+mj-lt"/>
+              <a:buAutoNum type="arabicPeriod"/>
+            </a:pPr>
+            <a:r>
+              <a:rPr lang="de-DE" sz="1400" dirty="0" err="1">
+                <a:solidFill>
+                  <a:srgbClr val="FF0000"/>
+                </a:solidFill>
+              </a:rPr>
+              <a:t>to</a:t>
+            </a:r>
+            <a:r>
+              <a:rPr lang="de-DE" sz="1400" dirty="0">
+                <a:solidFill>
+                  <a:srgbClr val="FF0000"/>
+                </a:solidFill>
+              </a:rPr>
+              <a:t> </a:t>
+            </a:r>
+            <a:r>
+              <a:rPr lang="de-DE" sz="1400" dirty="0" err="1">
+                <a:solidFill>
+                  <a:srgbClr val="FF0000"/>
+                </a:solidFill>
+              </a:rPr>
+              <a:t>think</a:t>
+            </a:r>
+            <a:r>
+              <a:rPr lang="de-DE" sz="1400" dirty="0">
+                <a:solidFill>
+                  <a:srgbClr val="FF0000"/>
+                </a:solidFill>
+              </a:rPr>
+              <a:t> </a:t>
+            </a:r>
+            <a:r>
+              <a:rPr lang="de-DE" sz="1400" dirty="0" err="1">
+                <a:solidFill>
+                  <a:srgbClr val="FF0000"/>
+                </a:solidFill>
+              </a:rPr>
+              <a:t>click</a:t>
+            </a:r>
+            <a:r>
+              <a:rPr lang="de-DE" sz="1400" dirty="0">
+                <a:solidFill>
+                  <a:srgbClr val="FF0000"/>
+                </a:solidFill>
+              </a:rPr>
+              <a:t> a </a:t>
+            </a:r>
+            <a:r>
+              <a:rPr lang="de-DE" sz="1400" dirty="0" err="1">
+                <a:solidFill>
+                  <a:srgbClr val="FF0000"/>
+                </a:solidFill>
+              </a:rPr>
+              <a:t>button</a:t>
+            </a:r>
+            <a:r>
+              <a:rPr lang="de-DE" sz="1400" dirty="0">
+                <a:solidFill>
+                  <a:srgbClr val="FF0000"/>
+                </a:solidFill>
+              </a:rPr>
+              <a:t> </a:t>
+            </a:r>
+            <a:r>
+              <a:rPr lang="de-DE" sz="1400" dirty="0" err="1">
+                <a:solidFill>
+                  <a:srgbClr val="FF0000"/>
+                </a:solidFill>
+              </a:rPr>
+              <a:t>to</a:t>
+            </a:r>
+            <a:r>
+              <a:rPr lang="de-DE" sz="1400" dirty="0">
+                <a:solidFill>
+                  <a:srgbClr val="FF0000"/>
+                </a:solidFill>
+              </a:rPr>
+              <a:t> open a </a:t>
+            </a:r>
+            <a:r>
+              <a:rPr lang="de-DE" sz="1400" dirty="0" err="1">
+                <a:solidFill>
+                  <a:srgbClr val="FF0000"/>
+                </a:solidFill>
+              </a:rPr>
+              <a:t>new</a:t>
+            </a:r>
+            <a:r>
+              <a:rPr lang="de-DE" sz="1400" dirty="0">
+                <a:solidFill>
+                  <a:srgbClr val="FF0000"/>
+                </a:solidFill>
+              </a:rPr>
+              <a:t> </a:t>
+            </a:r>
+            <a:r>
+              <a:rPr lang="de-DE" sz="1400" dirty="0" err="1">
+                <a:solidFill>
+                  <a:srgbClr val="FF0000"/>
+                </a:solidFill>
+              </a:rPr>
+              <a:t>tab</a:t>
+            </a:r>
+            <a:endParaRPr lang="de-DE" sz="1400" dirty="0">
+              <a:solidFill>
+                <a:srgbClr val="FF0000"/>
+              </a:solidFill>
+            </a:endParaRPr>
+          </a:p>
+          <a:p>
+            <a:pPr marL="342900" indent="-342900">
+              <a:buFont typeface="+mj-lt"/>
+              <a:buAutoNum type="arabicPeriod"/>
+            </a:pPr>
+            <a:r>
+              <a:rPr lang="de-DE" sz="1400" dirty="0" err="1"/>
+              <a:t>look</a:t>
+            </a:r>
+            <a:r>
+              <a:rPr lang="de-DE" sz="1400" dirty="0"/>
+              <a:t> </a:t>
+            </a:r>
+            <a:r>
+              <a:rPr lang="de-DE" sz="1400" dirty="0" err="1"/>
+              <a:t>the</a:t>
+            </a:r>
+            <a:r>
+              <a:rPr lang="de-DE" sz="1400" dirty="0"/>
+              <a:t> </a:t>
+            </a:r>
+            <a:r>
+              <a:rPr lang="de-DE" sz="1400" dirty="0" err="1"/>
+              <a:t>fundamentals</a:t>
+            </a:r>
+            <a:r>
+              <a:rPr lang="de-DE" sz="1400" dirty="0"/>
+              <a:t> </a:t>
+            </a:r>
+            <a:r>
+              <a:rPr lang="de-DE" sz="1400" dirty="0" err="1"/>
+              <a:t>of</a:t>
+            </a:r>
+            <a:r>
+              <a:rPr lang="de-DE" sz="1400" dirty="0"/>
+              <a:t> EPICS ?</a:t>
+            </a:r>
+          </a:p>
+          <a:p>
+            <a:pPr marL="342900" indent="-342900">
+              <a:buFont typeface="+mj-lt"/>
+              <a:buAutoNum type="arabicPeriod"/>
+            </a:pPr>
+            <a:r>
+              <a:rPr lang="de-DE" sz="1400" strike="sngStrike" dirty="0"/>
+              <a:t>SFC </a:t>
+            </a:r>
+            <a:r>
+              <a:rPr lang="de-DE" sz="1400" strike="sngStrike" dirty="0" err="1"/>
+              <a:t>presentation</a:t>
+            </a:r>
+            <a:endParaRPr lang="de-DE" sz="1400" strike="sngStrike" dirty="0"/>
+          </a:p>
+          <a:p>
+            <a:pPr marL="342900" indent="-342900">
+              <a:buFont typeface="+mj-lt"/>
+              <a:buAutoNum type="arabicPeriod"/>
+            </a:pPr>
+            <a:endParaRPr lang="de-DE" sz="1400" dirty="0"/>
+          </a:p>
+          <a:p>
+            <a:pPr marL="342900" indent="-342900">
+              <a:buFont typeface="+mj-lt"/>
+              <a:buAutoNum type="arabicPeriod"/>
+            </a:pPr>
+            <a:endParaRPr lang="de-DE" sz="1400" dirty="0"/>
+          </a:p>
+          <a:p>
+            <a:pPr marL="342900" indent="-342900">
+              <a:buFont typeface="+mj-lt"/>
+              <a:buAutoNum type="arabicPeriod"/>
+            </a:pPr>
+            <a:endParaRPr lang="de-DE" sz="1400" dirty="0"/>
+          </a:p>
+          <a:p>
+            <a:pPr marL="342900" indent="-342900">
+              <a:buFont typeface="+mj-lt"/>
+              <a:buAutoNum type="arabicPeriod"/>
+            </a:pPr>
+            <a:endParaRPr lang="de-DE" sz="1400" dirty="0"/>
+          </a:p>
+          <a:p>
+            <a:pPr marL="0" indent="0">
+              <a:buNone/>
+            </a:pPr>
+            <a:endParaRPr lang="de-DE" sz="1400" dirty="0"/>
+          </a:p>
+          <a:p>
+            <a:pPr marL="0" indent="0">
+              <a:buNone/>
+            </a:pPr>
+            <a:r>
+              <a:rPr lang="de-DE" b="1" dirty="0"/>
+              <a:t>Questions / </a:t>
+            </a:r>
+            <a:r>
+              <a:rPr lang="de-DE" b="1" dirty="0" err="1"/>
+              <a:t>Ideas</a:t>
+            </a:r>
+            <a:endParaRPr lang="de-DE" b="1" dirty="0"/>
+          </a:p>
+          <a:p>
+            <a:pPr marL="342900" indent="-342900">
+              <a:buFont typeface="+mj-lt"/>
+              <a:buAutoNum type="arabicPeriod"/>
+            </a:pPr>
+            <a:r>
+              <a:rPr lang="de-DE" sz="1400" dirty="0" err="1"/>
+              <a:t>multistate</a:t>
+            </a:r>
+            <a:r>
+              <a:rPr lang="de-DE" sz="1400" dirty="0"/>
+              <a:t> </a:t>
+            </a:r>
+            <a:r>
+              <a:rPr lang="de-DE" sz="1400" dirty="0" err="1"/>
+              <a:t>leds</a:t>
+            </a:r>
+            <a:r>
+              <a:rPr lang="de-DE" sz="1400" dirty="0"/>
+              <a:t> </a:t>
+            </a:r>
+            <a:r>
+              <a:rPr lang="de-DE" sz="1400" dirty="0" err="1"/>
+              <a:t>make</a:t>
+            </a:r>
+            <a:r>
+              <a:rPr lang="de-DE" sz="1400" dirty="0"/>
+              <a:t> </a:t>
+            </a:r>
+            <a:r>
+              <a:rPr lang="de-DE" sz="1400" dirty="0" err="1"/>
+              <a:t>error</a:t>
+            </a:r>
+            <a:r>
+              <a:rPr lang="de-DE" sz="1400" dirty="0"/>
+              <a:t>, </a:t>
+            </a:r>
+            <a:r>
+              <a:rPr lang="de-DE" sz="1400" dirty="0" err="1"/>
+              <a:t>warning</a:t>
+            </a:r>
+            <a:r>
+              <a:rPr lang="de-DE" sz="1400" dirty="0"/>
+              <a:t>, ok</a:t>
+            </a:r>
+          </a:p>
+          <a:p>
+            <a:pPr marL="342900" indent="-342900">
+              <a:buFont typeface="+mj-lt"/>
+              <a:buAutoNum type="arabicPeriod"/>
+            </a:pPr>
+            <a:r>
+              <a:rPr lang="de-DE" sz="1400" dirty="0" err="1"/>
+              <a:t>for</a:t>
+            </a:r>
+            <a:r>
+              <a:rPr lang="de-DE" sz="1400" dirty="0"/>
+              <a:t> </a:t>
+            </a:r>
+            <a:r>
+              <a:rPr lang="de-DE" sz="1400" dirty="0" err="1"/>
+              <a:t>plsci</a:t>
+            </a:r>
+            <a:r>
+              <a:rPr lang="de-DE" sz="1400" dirty="0"/>
+              <a:t> </a:t>
+            </a:r>
+            <a:r>
+              <a:rPr lang="de-DE" sz="1400" dirty="0" err="1"/>
+              <a:t>it</a:t>
+            </a:r>
+            <a:r>
+              <a:rPr lang="de-DE" sz="1400" dirty="0"/>
+              <a:t> </a:t>
+            </a:r>
+            <a:r>
+              <a:rPr lang="de-DE" sz="1400" dirty="0" err="1"/>
+              <a:t>may</a:t>
+            </a:r>
+            <a:r>
+              <a:rPr lang="de-DE" sz="1400" dirty="0"/>
+              <a:t> </a:t>
+            </a:r>
+            <a:r>
+              <a:rPr lang="de-DE" sz="1400" dirty="0" err="1"/>
+              <a:t>be</a:t>
+            </a:r>
+            <a:r>
+              <a:rPr lang="de-DE" sz="1400" dirty="0"/>
+              <a:t> </a:t>
+            </a:r>
+            <a:r>
+              <a:rPr lang="de-DE" sz="1400" dirty="0" err="1"/>
+              <a:t>used</a:t>
+            </a:r>
+            <a:r>
+              <a:rPr lang="de-DE" sz="1400" dirty="0"/>
+              <a:t> tank/</a:t>
+            </a:r>
+            <a:r>
+              <a:rPr lang="de-DE" sz="1400" dirty="0" err="1"/>
+              <a:t>progress</a:t>
+            </a:r>
+            <a:r>
+              <a:rPr lang="de-DE" sz="1400" dirty="0"/>
+              <a:t> bar </a:t>
+            </a:r>
+            <a:r>
+              <a:rPr lang="de-DE" sz="1400" dirty="0" err="1"/>
+              <a:t>for</a:t>
+            </a:r>
+            <a:r>
+              <a:rPr lang="de-DE" sz="1400" dirty="0"/>
+              <a:t> HV_I_RBV</a:t>
+            </a:r>
+          </a:p>
+          <a:p>
+            <a:pPr marL="300038" lvl="1" indent="0">
+              <a:buNone/>
+            </a:pPr>
+            <a:endParaRPr lang="de-DE" sz="1000" dirty="0"/>
+          </a:p>
+        </p:txBody>
+      </p:sp>
+    </p:spTree>
+    <p:extLst>
+      <p:ext uri="{BB962C8B-B14F-4D97-AF65-F5344CB8AC3E}">
+        <p14:creationId xmlns:p14="http://schemas.microsoft.com/office/powerpoint/2010/main" val="1043004298"/>
+      </p:ext>
+    </p:extLst>
+  </p:cSld>
+  <p:clrMapOvr>
+    <a:masterClrMapping/>
+  </p:clrMapOvr>
+</p:sld>
+</file>
+
+<file path=ppt/slides/slide26.xml><?xml version="1.0" encoding="utf-8"?>
+<p:sld xmlns:a="http://schemas.openxmlformats.org/drawingml/2006/main" xmlns:r="http://schemas.openxmlformats.org/officeDocument/2006/relationships" xmlns:p="http://schemas.openxmlformats.org/presentationml/2006/main">
+  <p:cSld>
+    <p:spTree>
+      <p:nvGrpSpPr>
+        <p:cNvPr id="1" name=""/>
+        <p:cNvGrpSpPr/>
+        <p:nvPr/>
+      </p:nvGrpSpPr>
+      <p:grpSpPr>
+        <a:xfrm>
+          <a:off x="0" y="0"/>
+          <a:ext cx="0" cy="0"/>
+          <a:chOff x="0" y="0"/>
+          <a:chExt cx="0" cy="0"/>
+        </a:xfrm>
+      </p:grpSpPr>
+      <p:sp>
+        <p:nvSpPr>
+          <p:cNvPr id="2" name="Title 1">
+            <a:extLst>
+              <a:ext uri="{FF2B5EF4-FFF2-40B4-BE49-F238E27FC236}">
+                <a16:creationId xmlns:a16="http://schemas.microsoft.com/office/drawing/2014/main" id="{C4F020AE-CD6F-4C87-8B44-2242F3095430}"/>
+              </a:ext>
+            </a:extLst>
+          </p:cNvPr>
+          <p:cNvSpPr>
+            <a:spLocks noGrp="1"/>
+          </p:cNvSpPr>
+          <p:nvPr>
+            <p:ph type="title"/>
+          </p:nvPr>
+        </p:nvSpPr>
+        <p:spPr/>
+        <p:txBody>
+          <a:bodyPr/>
+          <a:lstStyle/>
+          <a:p>
+            <a:r>
+              <a:rPr lang="de-DE" dirty="0"/>
+              <a:t>Report 26.09.02</a:t>
+            </a:r>
+          </a:p>
+        </p:txBody>
+      </p:sp>
+      <p:sp>
+        <p:nvSpPr>
+          <p:cNvPr id="4" name="Content Placeholder 2">
+            <a:extLst>
+              <a:ext uri="{FF2B5EF4-FFF2-40B4-BE49-F238E27FC236}">
+                <a16:creationId xmlns:a16="http://schemas.microsoft.com/office/drawing/2014/main" id="{FA77772D-0DBC-49CF-A5F5-2F8530CE8539}"/>
+              </a:ext>
+            </a:extLst>
+          </p:cNvPr>
+          <p:cNvSpPr>
+            <a:spLocks noGrp="1"/>
+          </p:cNvSpPr>
+          <p:nvPr>
+            <p:ph idx="1"/>
+          </p:nvPr>
+        </p:nvSpPr>
+        <p:spPr>
+          <a:xfrm>
+            <a:off x="317500" y="1087438"/>
+            <a:ext cx="8420100" cy="3678237"/>
+          </a:xfrm>
+        </p:spPr>
+        <p:txBody>
+          <a:bodyPr/>
+          <a:lstStyle/>
+          <a:p>
+            <a:pPr marL="0" indent="0">
+              <a:buNone/>
+            </a:pPr>
+            <a:r>
+              <a:rPr lang="de-DE" b="1" dirty="0" err="1"/>
+              <a:t>Suggested</a:t>
+            </a:r>
+            <a:endParaRPr lang="de-DE" b="1" dirty="0"/>
+          </a:p>
+          <a:p>
+            <a:pPr marL="342900" indent="-342900">
+              <a:buFont typeface="+mj-lt"/>
+              <a:buAutoNum type="arabicPeriod"/>
+            </a:pPr>
+            <a:r>
+              <a:rPr lang="de-DE" sz="1400" strike="sngStrike" dirty="0" err="1">
+                <a:solidFill>
+                  <a:srgbClr val="FF0000"/>
+                </a:solidFill>
+              </a:rPr>
+              <a:t>to</a:t>
+            </a:r>
+            <a:r>
+              <a:rPr lang="de-DE" sz="1400" strike="sngStrike" dirty="0">
+                <a:solidFill>
+                  <a:srgbClr val="FF0000"/>
+                </a:solidFill>
+              </a:rPr>
+              <a:t> </a:t>
+            </a:r>
+            <a:r>
+              <a:rPr lang="de-DE" sz="1400" strike="sngStrike" dirty="0" err="1">
+                <a:solidFill>
+                  <a:srgbClr val="FF0000"/>
+                </a:solidFill>
+              </a:rPr>
+              <a:t>think</a:t>
+            </a:r>
+            <a:r>
+              <a:rPr lang="de-DE" sz="1400" strike="sngStrike" dirty="0">
+                <a:solidFill>
+                  <a:srgbClr val="FF0000"/>
+                </a:solidFill>
+              </a:rPr>
+              <a:t> </a:t>
+            </a:r>
+            <a:r>
+              <a:rPr lang="de-DE" sz="1400" strike="sngStrike" dirty="0" err="1">
+                <a:solidFill>
+                  <a:srgbClr val="FF0000"/>
+                </a:solidFill>
+              </a:rPr>
+              <a:t>click</a:t>
+            </a:r>
+            <a:r>
+              <a:rPr lang="de-DE" sz="1400" strike="sngStrike" dirty="0">
+                <a:solidFill>
+                  <a:srgbClr val="FF0000"/>
+                </a:solidFill>
+              </a:rPr>
+              <a:t> a </a:t>
+            </a:r>
+            <a:r>
+              <a:rPr lang="de-DE" sz="1400" strike="sngStrike" dirty="0" err="1">
+                <a:solidFill>
+                  <a:srgbClr val="FF0000"/>
+                </a:solidFill>
+              </a:rPr>
+              <a:t>button</a:t>
+            </a:r>
+            <a:r>
+              <a:rPr lang="de-DE" sz="1400" strike="sngStrike" dirty="0">
+                <a:solidFill>
+                  <a:srgbClr val="FF0000"/>
+                </a:solidFill>
+              </a:rPr>
+              <a:t> </a:t>
+            </a:r>
+            <a:r>
+              <a:rPr lang="de-DE" sz="1400" strike="sngStrike" dirty="0" err="1">
+                <a:solidFill>
+                  <a:srgbClr val="FF0000"/>
+                </a:solidFill>
+              </a:rPr>
+              <a:t>to</a:t>
+            </a:r>
+            <a:r>
+              <a:rPr lang="de-DE" sz="1400" strike="sngStrike" dirty="0">
+                <a:solidFill>
+                  <a:srgbClr val="FF0000"/>
+                </a:solidFill>
+              </a:rPr>
+              <a:t> open a </a:t>
+            </a:r>
+            <a:r>
+              <a:rPr lang="de-DE" sz="1400" strike="sngStrike" dirty="0" err="1">
+                <a:solidFill>
+                  <a:srgbClr val="FF0000"/>
+                </a:solidFill>
+              </a:rPr>
+              <a:t>new</a:t>
+            </a:r>
+            <a:r>
+              <a:rPr lang="de-DE" sz="1400" strike="sngStrike" dirty="0">
+                <a:solidFill>
+                  <a:srgbClr val="FF0000"/>
+                </a:solidFill>
+              </a:rPr>
+              <a:t> </a:t>
+            </a:r>
+            <a:r>
+              <a:rPr lang="de-DE" sz="1400" strike="sngStrike" dirty="0" err="1">
+                <a:solidFill>
+                  <a:srgbClr val="FF0000"/>
+                </a:solidFill>
+              </a:rPr>
+              <a:t>tab</a:t>
+            </a:r>
+            <a:r>
+              <a:rPr lang="de-DE" sz="1400" strike="sngStrike" dirty="0">
+                <a:solidFill>
+                  <a:srgbClr val="FF0000"/>
+                </a:solidFill>
+              </a:rPr>
+              <a:t> (Status </a:t>
+            </a:r>
+            <a:r>
+              <a:rPr lang="de-DE" sz="1400" strike="sngStrike" dirty="0" err="1">
+                <a:solidFill>
+                  <a:srgbClr val="FF0000"/>
+                </a:solidFill>
+              </a:rPr>
+              <a:t>information</a:t>
+            </a:r>
+            <a:r>
+              <a:rPr lang="de-DE" sz="1400" strike="sngStrike" dirty="0">
+                <a:solidFill>
+                  <a:srgbClr val="FF0000"/>
+                </a:solidFill>
+              </a:rPr>
+              <a:t> box will </a:t>
+            </a:r>
+            <a:r>
+              <a:rPr lang="de-DE" sz="1400" strike="sngStrike" dirty="0" err="1">
+                <a:solidFill>
+                  <a:srgbClr val="FF0000"/>
+                </a:solidFill>
+              </a:rPr>
+              <a:t>be</a:t>
+            </a:r>
+            <a:r>
+              <a:rPr lang="de-DE" sz="1400" strike="sngStrike" dirty="0">
+                <a:solidFill>
+                  <a:srgbClr val="FF0000"/>
+                </a:solidFill>
+              </a:rPr>
+              <a:t> </a:t>
+            </a:r>
+            <a:r>
+              <a:rPr lang="de-DE" sz="1400" strike="sngStrike" dirty="0" err="1">
+                <a:solidFill>
+                  <a:srgbClr val="FF0000"/>
+                </a:solidFill>
+              </a:rPr>
+              <a:t>tried</a:t>
+            </a:r>
+            <a:r>
+              <a:rPr lang="de-DE" sz="1400" strike="sngStrike" dirty="0">
+                <a:solidFill>
+                  <a:srgbClr val="FF0000"/>
+                </a:solidFill>
+              </a:rPr>
+              <a:t> </a:t>
+            </a:r>
+            <a:r>
+              <a:rPr lang="de-DE" sz="1400" strike="sngStrike" dirty="0" err="1">
+                <a:solidFill>
+                  <a:srgbClr val="FF0000"/>
+                </a:solidFill>
+              </a:rPr>
+              <a:t>today</a:t>
+            </a:r>
+            <a:r>
+              <a:rPr lang="de-DE" sz="1400" strike="sngStrike" dirty="0">
+                <a:solidFill>
+                  <a:srgbClr val="FF0000"/>
+                </a:solidFill>
+              </a:rPr>
+              <a:t>)</a:t>
+            </a:r>
+          </a:p>
+          <a:p>
+            <a:pPr marL="342900" indent="-342900">
+              <a:buFont typeface="+mj-lt"/>
+              <a:buAutoNum type="arabicPeriod"/>
+            </a:pPr>
+            <a:r>
+              <a:rPr lang="de-DE" sz="1400" dirty="0" err="1"/>
+              <a:t>look</a:t>
+            </a:r>
+            <a:r>
+              <a:rPr lang="de-DE" sz="1400" dirty="0"/>
+              <a:t> </a:t>
+            </a:r>
+            <a:r>
+              <a:rPr lang="de-DE" sz="1400" dirty="0" err="1"/>
+              <a:t>the</a:t>
+            </a:r>
+            <a:r>
+              <a:rPr lang="de-DE" sz="1400" dirty="0"/>
+              <a:t> </a:t>
+            </a:r>
+            <a:r>
+              <a:rPr lang="de-DE" sz="1400" dirty="0" err="1"/>
+              <a:t>fundamentals</a:t>
+            </a:r>
+            <a:r>
+              <a:rPr lang="de-DE" sz="1400" dirty="0"/>
+              <a:t> </a:t>
+            </a:r>
+            <a:r>
+              <a:rPr lang="de-DE" sz="1400" dirty="0" err="1"/>
+              <a:t>of</a:t>
+            </a:r>
+            <a:r>
+              <a:rPr lang="de-DE" sz="1400" dirty="0"/>
+              <a:t> EPICS ? (</a:t>
+            </a:r>
+            <a:r>
+              <a:rPr lang="de-DE" sz="1400" dirty="0" err="1"/>
+              <a:t>one</a:t>
+            </a:r>
+            <a:r>
+              <a:rPr lang="de-DE" sz="1400" dirty="0"/>
+              <a:t> </a:t>
+            </a:r>
+            <a:r>
+              <a:rPr lang="de-DE" sz="1400" dirty="0" err="1"/>
+              <a:t>document</a:t>
+            </a:r>
+            <a:r>
+              <a:rPr lang="de-DE" sz="1400" dirty="0"/>
+              <a:t> </a:t>
+            </a:r>
+            <a:r>
+              <a:rPr lang="de-DE" sz="1400" dirty="0" err="1"/>
+              <a:t>from</a:t>
+            </a:r>
+            <a:r>
+              <a:rPr lang="de-DE" sz="1400" dirty="0"/>
+              <a:t> </a:t>
+            </a:r>
+            <a:r>
+              <a:rPr lang="de-DE" sz="1400" dirty="0" err="1"/>
+              <a:t>jan</a:t>
+            </a:r>
+            <a:r>
+              <a:rPr lang="de-DE" sz="1400" dirty="0"/>
+              <a:t>)</a:t>
+            </a:r>
+          </a:p>
+          <a:p>
+            <a:pPr marL="342900" indent="-342900">
+              <a:buFont typeface="+mj-lt"/>
+              <a:buAutoNum type="arabicPeriod"/>
+            </a:pPr>
+            <a:endParaRPr lang="de-DE" sz="1400" dirty="0"/>
+          </a:p>
+          <a:p>
+            <a:pPr marL="342900" indent="-342900">
+              <a:buFont typeface="+mj-lt"/>
+              <a:buAutoNum type="arabicPeriod"/>
+            </a:pPr>
+            <a:endParaRPr lang="de-DE" sz="1400" dirty="0"/>
+          </a:p>
+          <a:p>
+            <a:pPr marL="342900" indent="-342900">
+              <a:buFont typeface="+mj-lt"/>
+              <a:buAutoNum type="arabicPeriod"/>
+            </a:pPr>
+            <a:endParaRPr lang="de-DE" sz="1400" dirty="0"/>
+          </a:p>
+          <a:p>
+            <a:pPr marL="342900" indent="-342900">
+              <a:buFont typeface="+mj-lt"/>
+              <a:buAutoNum type="arabicPeriod"/>
+            </a:pPr>
+            <a:endParaRPr lang="de-DE" sz="1400" dirty="0"/>
+          </a:p>
+          <a:p>
+            <a:pPr marL="0" indent="0">
+              <a:buNone/>
+            </a:pPr>
+            <a:endParaRPr lang="de-DE" sz="1400" dirty="0"/>
+          </a:p>
+          <a:p>
+            <a:pPr marL="0" indent="0">
+              <a:buNone/>
+            </a:pPr>
+            <a:r>
+              <a:rPr lang="de-DE" b="1" dirty="0"/>
+              <a:t>Questions / </a:t>
+            </a:r>
+            <a:r>
+              <a:rPr lang="de-DE" b="1" dirty="0" err="1"/>
+              <a:t>Ideas</a:t>
+            </a:r>
+            <a:endParaRPr lang="de-DE" b="1" dirty="0"/>
+          </a:p>
+          <a:p>
+            <a:pPr marL="342900" indent="-342900">
+              <a:buFont typeface="+mj-lt"/>
+              <a:buAutoNum type="arabicPeriod"/>
+            </a:pPr>
+            <a:r>
+              <a:rPr lang="de-DE" sz="1400" dirty="0" err="1"/>
+              <a:t>multistate</a:t>
+            </a:r>
+            <a:r>
+              <a:rPr lang="de-DE" sz="1400" dirty="0"/>
+              <a:t> </a:t>
+            </a:r>
+            <a:r>
+              <a:rPr lang="de-DE" sz="1400" dirty="0" err="1"/>
+              <a:t>leds</a:t>
+            </a:r>
+            <a:r>
+              <a:rPr lang="de-DE" sz="1400" dirty="0"/>
+              <a:t> </a:t>
+            </a:r>
+            <a:r>
+              <a:rPr lang="de-DE" sz="1400" dirty="0" err="1"/>
+              <a:t>make</a:t>
+            </a:r>
+            <a:r>
+              <a:rPr lang="de-DE" sz="1400" dirty="0"/>
+              <a:t> </a:t>
+            </a:r>
+            <a:r>
+              <a:rPr lang="de-DE" sz="1400" dirty="0" err="1"/>
+              <a:t>error</a:t>
+            </a:r>
+            <a:r>
+              <a:rPr lang="de-DE" sz="1400" dirty="0"/>
+              <a:t>, </a:t>
+            </a:r>
+            <a:r>
+              <a:rPr lang="de-DE" sz="1400" dirty="0" err="1"/>
+              <a:t>warning</a:t>
+            </a:r>
+            <a:r>
+              <a:rPr lang="de-DE" sz="1400" dirty="0"/>
+              <a:t>, ok</a:t>
+            </a:r>
+          </a:p>
+          <a:p>
+            <a:pPr marL="342900" indent="-342900">
+              <a:buFont typeface="+mj-lt"/>
+              <a:buAutoNum type="arabicPeriod"/>
+            </a:pPr>
+            <a:r>
+              <a:rPr lang="de-DE" sz="1400" dirty="0" err="1"/>
+              <a:t>for</a:t>
+            </a:r>
+            <a:r>
+              <a:rPr lang="de-DE" sz="1400" dirty="0"/>
+              <a:t> </a:t>
+            </a:r>
+            <a:r>
+              <a:rPr lang="de-DE" sz="1400" dirty="0" err="1"/>
+              <a:t>plsci</a:t>
+            </a:r>
+            <a:r>
+              <a:rPr lang="de-DE" sz="1400" dirty="0"/>
+              <a:t> </a:t>
+            </a:r>
+            <a:r>
+              <a:rPr lang="de-DE" sz="1400" dirty="0" err="1"/>
+              <a:t>it</a:t>
+            </a:r>
+            <a:r>
+              <a:rPr lang="de-DE" sz="1400" dirty="0"/>
+              <a:t> </a:t>
+            </a:r>
+            <a:r>
+              <a:rPr lang="de-DE" sz="1400" dirty="0" err="1"/>
+              <a:t>may</a:t>
+            </a:r>
+            <a:r>
+              <a:rPr lang="de-DE" sz="1400" dirty="0"/>
+              <a:t> </a:t>
+            </a:r>
+            <a:r>
+              <a:rPr lang="de-DE" sz="1400" dirty="0" err="1"/>
+              <a:t>be</a:t>
+            </a:r>
+            <a:r>
+              <a:rPr lang="de-DE" sz="1400" dirty="0"/>
+              <a:t> </a:t>
+            </a:r>
+            <a:r>
+              <a:rPr lang="de-DE" sz="1400" dirty="0" err="1"/>
+              <a:t>used</a:t>
+            </a:r>
+            <a:r>
+              <a:rPr lang="de-DE" sz="1400" dirty="0"/>
+              <a:t> tank/</a:t>
+            </a:r>
+            <a:r>
+              <a:rPr lang="de-DE" sz="1400" dirty="0" err="1"/>
+              <a:t>progress</a:t>
+            </a:r>
+            <a:r>
+              <a:rPr lang="de-DE" sz="1400" dirty="0"/>
+              <a:t> bar </a:t>
+            </a:r>
+            <a:r>
+              <a:rPr lang="de-DE" sz="1400" dirty="0" err="1"/>
+              <a:t>for</a:t>
+            </a:r>
+            <a:r>
+              <a:rPr lang="de-DE" sz="1400" dirty="0"/>
+              <a:t> HV_I_RBV</a:t>
+            </a:r>
+          </a:p>
+          <a:p>
+            <a:pPr marL="300038" lvl="1" indent="0">
+              <a:buNone/>
+            </a:pPr>
+            <a:endParaRPr lang="de-DE" sz="1000" dirty="0"/>
+          </a:p>
+        </p:txBody>
+      </p:sp>
+    </p:spTree>
+    <p:extLst>
+      <p:ext uri="{BB962C8B-B14F-4D97-AF65-F5344CB8AC3E}">
+        <p14:creationId xmlns:p14="http://schemas.microsoft.com/office/powerpoint/2010/main" val="1029446538"/>
       </p:ext>
     </p:extLst>
   </p:cSld>

</xml_diff>